<commit_message>
docs & slides: incorporate senior feedback, Yahoo Finance 159m data explanation, and Exhibit 5 candidate breakdown
</commit_message>
<xml_diff>
--- a/The_Self_Driving_Portfolio_중간발표_최종본.pptx
+++ b/The_Self_Driving_Portfolio_중간발표_최종본.pptx
@@ -3197,7 +3197,7 @@
         </p:nvSpPr>
         <p:spPr>
           <a:xfrm>
-            <a:off x="914400" y="2011680"/>
+            <a:off x="914400" y="1828800"/>
             <a:ext cx="10058400" cy="457200"/>
           </a:xfrm>
           <a:prstGeom prst="rect">
@@ -3236,7 +3236,7 @@
         </p:nvSpPr>
         <p:spPr>
           <a:xfrm>
-            <a:off x="914400" y="2468880"/>
+            <a:off x="914400" y="2286000"/>
             <a:ext cx="10058400" cy="914400"/>
           </a:xfrm>
           <a:prstGeom prst="rect">
@@ -3275,7 +3275,7 @@
         </p:nvSpPr>
         <p:spPr>
           <a:xfrm>
-            <a:off x="914400" y="3383280"/>
+            <a:off x="914400" y="3246120"/>
             <a:ext cx="10058400" cy="548640"/>
           </a:xfrm>
           <a:prstGeom prst="rect">
@@ -3301,7 +3301,7 @@
                 </a:solidFill>
                 <a:latin typeface="Malgun Gothic"/>
               </a:rPr>
-              <a:t>멀티 에이전트 기반 기관 전략적 자산배분(SAA) 시스템 구현</a:t>
+              <a:t>투자위원회 의사결정 지원을 위한 AI Co-Pilot (Decision Support System)</a:t>
             </a:r>
           </a:p>
         </p:txBody>
@@ -3314,7 +3314,7 @@
         </p:nvSpPr>
         <p:spPr>
           <a:xfrm>
-            <a:off x="914400" y="4206240"/>
+            <a:off x="914400" y="4069080"/>
             <a:ext cx="1097280" cy="27432"/>
           </a:xfrm>
           <a:prstGeom prst="rect">
@@ -3358,7 +3358,7 @@
         </p:nvSpPr>
         <p:spPr>
           <a:xfrm>
-            <a:off x="914400" y="4434840"/>
+            <a:off x="914400" y="4343400"/>
             <a:ext cx="10058400" cy="365760"/>
           </a:xfrm>
           <a:prstGeom prst="rect">
@@ -3397,7 +3397,7 @@
         </p:nvSpPr>
         <p:spPr>
           <a:xfrm>
-            <a:off x="914400" y="4800600"/>
+            <a:off x="914400" y="4709160"/>
             <a:ext cx="10058400" cy="365760"/>
           </a:xfrm>
           <a:prstGeom prst="rect">
@@ -3563,7 +3563,7 @@
                 </a:solidFill>
                 <a:latin typeface="Malgun Gothic"/>
               </a:rPr>
-              <a:t>18개 자산군별 최종 권고 비중 (Exhibit 11)</a:t>
+              <a:t>18개 자산군별 최종 권고 비중 및 21개 후보군 (Exhibit 11)</a:t>
             </a:r>
           </a:p>
         </p:txBody>
@@ -3747,7 +3747,7 @@
         </p:nvSpPr>
         <p:spPr>
           <a:xfrm>
-            <a:off x="749808" y="1691640"/>
+            <a:off x="749808" y="1664208"/>
             <a:ext cx="3438144" cy="411480"/>
           </a:xfrm>
           <a:prstGeom prst="rect">
@@ -3767,13 +3767,13 @@
               </a:spcAft>
             </a:pPr>
             <a:r>
-              <a:rPr sz="1800" b="1">
+              <a:rPr sz="1700" b="1">
                 <a:solidFill>
                   <a:srgbClr val="051C2C"/>
                 </a:solidFill>
                 <a:latin typeface="Malgun Gothic"/>
               </a:rPr>
-              <a:t>포트폴리오 비중 특징</a:t>
+              <a:t>후보군 21개 모델 및 최종 비중</a:t>
             </a:r>
           </a:p>
         </p:txBody>
@@ -3786,8 +3786,8 @@
         </p:nvSpPr>
         <p:spPr>
           <a:xfrm>
-            <a:off x="749808" y="2240280"/>
-            <a:ext cx="3438144" cy="3703320"/>
+            <a:off x="749808" y="2176272"/>
+            <a:ext cx="3438144" cy="3767328"/>
           </a:xfrm>
           <a:prstGeom prst="rect">
             <a:avLst/>
@@ -3806,12 +3806,92 @@
               </a:spcAft>
             </a:pPr>
             <a:r>
-              <a:rPr sz="1250" b="0">
+              <a:rPr sz="1200" b="0">
                 <a:solidFill>
                   <a:srgbClr val="475569"/>
                 </a:solidFill>
                 <a:latin typeface="Malgun Gothic"/>
               </a:rPr>
+              <a:t>·  후보군: 논문 Exhibit 5 기반 4대 계열 21개 모델</a:t>
+            </a:r>
+          </a:p>
+          <a:p>
+            <a:pPr algn="l">
+              <a:spcAft>
+                <a:spcPts val="700"/>
+              </a:spcAft>
+            </a:pPr>
+            <a:r>
+              <a:rPr sz="1200" b="0">
+                <a:solidFill>
+                  <a:srgbClr val="475569"/>
+                </a:solidFill>
+                <a:latin typeface="Malgun Gothic"/>
+              </a:rPr>
+              <a:t>·  · A: 휴리스틱 5 (60/40, 동일가중, 모멘텀 등)</a:t>
+            </a:r>
+          </a:p>
+          <a:p>
+            <a:pPr algn="l">
+              <a:spcAft>
+                <a:spcPts val="700"/>
+              </a:spcAft>
+            </a:pPr>
+            <a:r>
+              <a:rPr sz="1200" b="0">
+                <a:solidFill>
+                  <a:srgbClr val="475569"/>
+                </a:solidFill>
+                <a:latin typeface="Malgun Gothic"/>
+              </a:rPr>
+              <a:t>·  · B: 수익률최적화 5 (MVO, 블랙-리터만 등)</a:t>
+            </a:r>
+          </a:p>
+          <a:p>
+            <a:pPr algn="l">
+              <a:spcAft>
+                <a:spcPts val="700"/>
+              </a:spcAft>
+            </a:pPr>
+            <a:r>
+              <a:rPr sz="1200" b="0">
+                <a:solidFill>
+                  <a:srgbClr val="475569"/>
+                </a:solidFill>
+                <a:latin typeface="Malgun Gothic"/>
+              </a:rPr>
+              <a:t>·  · C: 위험구조화 5 (위험균형, 최소분산, 최대분산 등)</a:t>
+            </a:r>
+          </a:p>
+          <a:p>
+            <a:pPr algn="l">
+              <a:spcAft>
+                <a:spcPts val="700"/>
+              </a:spcAft>
+            </a:pPr>
+            <a:r>
+              <a:rPr sz="1200" b="0">
+                <a:solidFill>
+                  <a:srgbClr val="475569"/>
+                </a:solidFill>
+                <a:latin typeface="Malgun Gothic"/>
+              </a:rPr>
+              <a:t>·  · D: 비전통 6 (TPA, 적대적분산, 최대엔트로피 등)</a:t>
+            </a:r>
+          </a:p>
+          <a:p>
+            <a:pPr algn="l">
+              <a:spcAft>
+                <a:spcPts val="700"/>
+              </a:spcAft>
+            </a:pPr>
+            <a:r>
+              <a:rPr sz="1200" b="0">
+                <a:solidFill>
+                  <a:srgbClr val="475569"/>
+                </a:solidFill>
+                <a:latin typeface="Malgun Gothic"/>
+              </a:rPr>
               <a:t>·  미국 대형주 (SPY): 28.56% (위험 기여 45.2%)</a:t>
             </a:r>
           </a:p>
@@ -3822,13 +3902,13 @@
               </a:spcAft>
             </a:pPr>
             <a:r>
-              <a:rPr sz="1250" b="0">
+              <a:rPr sz="1200" b="0">
                 <a:solidFill>
                   <a:srgbClr val="475569"/>
                 </a:solidFill>
                 <a:latin typeface="Malgun Gothic"/>
               </a:rPr>
-              <a:t>·  미국 중기국채 (IEF): 16.57% (핵심 안전판)</a:t>
+              <a:t>·  미국 중기국채 (IEF): 16.57% (포트폴리오 핵심 안전판)</a:t>
             </a:r>
           </a:p>
           <a:p>
@@ -3838,13 +3918,13 @@
               </a:spcAft>
             </a:pPr>
             <a:r>
-              <a:rPr sz="1250" b="0">
+              <a:rPr sz="1200" b="0">
                 <a:solidFill>
                   <a:srgbClr val="475569"/>
                 </a:solidFill>
                 <a:latin typeface="Malgun Gothic"/>
               </a:rPr>
-              <a:t>·  미국 성장주/가치주 (VUG/VTV): 각 9.41%</a:t>
+              <a:t>·  스타일 주식 (VUG/VTV): 각 9.41% 균형 배분</a:t>
             </a:r>
           </a:p>
           <a:p>
@@ -3854,77 +3934,13 @@
               </a:spcAft>
             </a:pPr>
             <a:r>
-              <a:rPr sz="1250" b="0">
+              <a:rPr sz="1200" b="0">
                 <a:solidFill>
                   <a:srgbClr val="475569"/>
                 </a:solidFill>
                 <a:latin typeface="Malgun Gothic"/>
               </a:rPr>
-              <a:t>·  미국 중소형주 (IWM): 5.59%</a:t>
-            </a:r>
-          </a:p>
-          <a:p>
-            <a:pPr algn="l">
-              <a:spcAft>
-                <a:spcPts val="700"/>
-              </a:spcAft>
-            </a:pPr>
-            <a:r>
-              <a:rPr sz="1250" b="0">
-                <a:solidFill>
-                  <a:srgbClr val="475569"/>
-                </a:solidFill>
-                <a:latin typeface="Malgun Gothic"/>
-              </a:rPr>
-              <a:t>·  미국 단기/장기국채 (SHY/TLT): 각 5.09%</a:t>
-            </a:r>
-          </a:p>
-          <a:p>
-            <a:pPr algn="l">
-              <a:spcAft>
-                <a:spcPts val="700"/>
-              </a:spcAft>
-            </a:pPr>
-            <a:r>
-              <a:rPr sz="1250" b="0">
-                <a:solidFill>
-                  <a:srgbClr val="475569"/>
-                </a:solidFill>
-                <a:latin typeface="Malgun Gothic"/>
-              </a:rPr>
-              <a:t>·  투자등급 회사채 (LQD): 5.09%</a:t>
-            </a:r>
-          </a:p>
-          <a:p>
-            <a:pPr algn="l">
-              <a:spcAft>
-                <a:spcPts val="700"/>
-              </a:spcAft>
-            </a:pPr>
-            <a:r>
-              <a:rPr sz="1250" b="0">
-                <a:solidFill>
-                  <a:srgbClr val="475569"/>
-                </a:solidFill>
-                <a:latin typeface="Malgun Gothic"/>
-              </a:rPr>
-              <a:t>·  해외 국채 (BNDX): 3.56%  |  HYG: 2.79%</a:t>
-            </a:r>
-          </a:p>
-          <a:p>
-            <a:pPr algn="l">
-              <a:spcAft>
-                <a:spcPts val="700"/>
-              </a:spcAft>
-            </a:pPr>
-            <a:r>
-              <a:rPr sz="1250" b="0">
-                <a:solidFill>
-                  <a:srgbClr val="475569"/>
-                </a:solidFill>
-                <a:latin typeface="Malgun Gothic"/>
-              </a:rPr>
-              <a:t>·  선진국/신흥국 주식 (EFA/EEM): 각 1.76%</a:t>
+              <a:t>·  단기/장기채 (SHY/TLT): 각 5.09% | 회사채: 5.09%</a:t>
             </a:r>
           </a:p>
         </p:txBody>
@@ -4134,7 +4150,7 @@
                 </a:solidFill>
                 <a:latin typeface="Malgun Gothic"/>
               </a:rPr>
-              <a:t>전략 심의: 수정 보르다 투표 결과 (Exhibit 9)</a:t>
+              <a:t>전략 심의: 수정 보르다 투표 및 IPS 적격 필터링 (Exhibit 9)</a:t>
             </a:r>
           </a:p>
         </p:txBody>
@@ -4318,7 +4334,7 @@
         </p:nvSpPr>
         <p:spPr>
           <a:xfrm>
-            <a:off x="749808" y="1691640"/>
+            <a:off x="749808" y="1664208"/>
             <a:ext cx="3438144" cy="411480"/>
           </a:xfrm>
           <a:prstGeom prst="rect">
@@ -4338,13 +4354,13 @@
               </a:spcAft>
             </a:pPr>
             <a:r>
-              <a:rPr sz="1800" b="1">
+              <a:rPr sz="1700" b="1">
                 <a:solidFill>
                   <a:srgbClr val="051C2C"/>
                 </a:solidFill>
                 <a:latin typeface="Malgun Gothic"/>
               </a:rPr>
-              <a:t>투표 결과 및 적격 심사</a:t>
+              <a:t>전략 심의 및 적격 필터링 진단</a:t>
             </a:r>
           </a:p>
         </p:txBody>
@@ -4357,8 +4373,8 @@
         </p:nvSpPr>
         <p:spPr>
           <a:xfrm>
-            <a:off x="749808" y="2240280"/>
-            <a:ext cx="3438144" cy="3703320"/>
+            <a:off x="749808" y="2176272"/>
+            <a:ext cx="3438144" cy="3767328"/>
           </a:xfrm>
           <a:prstGeom prst="rect">
             <a:avLst/>
@@ -4377,13 +4393,13 @@
               </a:spcAft>
             </a:pPr>
             <a:r>
-              <a:rPr sz="1250" b="0">
+              <a:rPr sz="1200" b="0">
                 <a:solidFill>
                   <a:srgbClr val="475569"/>
                 </a:solidFill>
                 <a:latin typeface="Malgun Gothic"/>
               </a:rPr>
-              <a:t>·  종합 점수: 동료 투표 55% + CRO 정량 45%</a:t>
+              <a:t>·  평가 점수: 동료 투표 55% + CRO 정량 점수 45%</a:t>
             </a:r>
           </a:p>
           <a:p>
@@ -4393,13 +4409,13 @@
               </a:spcAft>
             </a:pPr>
             <a:r>
-              <a:rPr sz="1250" b="0">
+              <a:rPr sz="1200" b="0">
                 <a:solidFill>
                   <a:srgbClr val="475569"/>
                 </a:solidFill>
                 <a:latin typeface="Malgun Gothic"/>
               </a:rPr>
-              <a:t>·  1위 최대 분산 (변동성 2.7% → 8% 미달 탈락)</a:t>
+              <a:t>·  상위 모델의 IPS 변동성 하한(8%) 미달 탈락:</a:t>
             </a:r>
           </a:p>
           <a:p>
@@ -4409,13 +4425,13 @@
               </a:spcAft>
             </a:pPr>
             <a:r>
-              <a:rPr sz="1250" b="0">
+              <a:rPr sz="1200" b="0">
                 <a:solidFill>
                   <a:srgbClr val="475569"/>
                 </a:solidFill>
                 <a:latin typeface="Malgun Gothic"/>
               </a:rPr>
-              <a:t>·  2위 블랙-리터만 (변동성 6.9% → 미달 탈락)</a:t>
+              <a:t>·  · 1위 최대 분산 (2.7%), 2위 BL (6.9%), 3위 위험균형 (6.5%)</a:t>
             </a:r>
           </a:p>
           <a:p>
@@ -4425,13 +4441,13 @@
               </a:spcAft>
             </a:pPr>
             <a:r>
-              <a:rPr sz="1250" b="0">
+              <a:rPr sz="1200" b="0">
                 <a:solidFill>
                   <a:srgbClr val="475569"/>
                 </a:solidFill>
                 <a:latin typeface="Malgun Gothic"/>
               </a:rPr>
-              <a:t>·  3위 위험균형 (변동성 6.5% → 미달 탈락)</a:t>
+              <a:t>·  4위 TPA (변동성 8.3%), 6위 시총가중 (9.2%)만 통과</a:t>
             </a:r>
           </a:p>
           <a:p>
@@ -4441,13 +4457,13 @@
               </a:spcAft>
             </a:pPr>
             <a:r>
-              <a:rPr sz="1250" b="0">
+              <a:rPr sz="1200" b="0">
                 <a:solidFill>
                   <a:srgbClr val="475569"/>
                 </a:solidFill>
                 <a:latin typeface="Malgun Gothic"/>
               </a:rPr>
-              <a:t>·  4위 TPA (변동성 8.3% → IPS 적격 통과)</a:t>
+              <a:t>·  엄격한 IPS 거버넌스 시연 vs 우수 알파 모델 누락</a:t>
             </a:r>
           </a:p>
           <a:p>
@@ -4457,13 +4473,13 @@
               </a:spcAft>
             </a:pPr>
             <a:r>
-              <a:rPr sz="1250" b="0">
+              <a:rPr sz="1200" b="0">
                 <a:solidFill>
                   <a:srgbClr val="475569"/>
                 </a:solidFill>
                 <a:latin typeface="Malgun Gothic"/>
               </a:rPr>
-              <a:t>·  6위 시가총액 가중 (변동성 9.2% → 적격 통과)</a:t>
+              <a:t>·  기말 해결책: 타깃 변동성 매칭(Vol Scaling) 도입</a:t>
             </a:r>
           </a:p>
           <a:p>
@@ -4473,13 +4489,13 @@
               </a:spcAft>
             </a:pPr>
             <a:r>
-              <a:rPr sz="1250" b="0">
+              <a:rPr sz="1200" b="0">
                 <a:solidFill>
                   <a:srgbClr val="475569"/>
                 </a:solidFill>
                 <a:latin typeface="Malgun Gothic"/>
               </a:rPr>
-              <a:t>·  적대적 분산 에이전트: 반대 관점 제기</a:t>
+              <a:t>·  적대적 분산 에이전트: 소수파 관점 및 편향 견제 기록</a:t>
             </a:r>
           </a:p>
           <a:p>
@@ -4489,13 +4505,13 @@
               </a:spcAft>
             </a:pPr>
             <a:r>
-              <a:rPr sz="1250" b="0">
+              <a:rPr sz="1200" b="0">
                 <a:solidFill>
                   <a:srgbClr val="475569"/>
                 </a:solidFill>
                 <a:latin typeface="Malgun Gothic"/>
               </a:rPr>
-              <a:t>·  결론: 적격 통과한 2개 모델만 앙상블 결합</a:t>
+              <a:t>·  최종 앙상블: 적격 2개 모델 역추적오차(TE) 결합</a:t>
             </a:r>
           </a:p>
         </p:txBody>
@@ -4705,7 +4721,7 @@
                 </a:solidFill>
                 <a:latin typeface="Malgun Gothic"/>
               </a:rPr>
-              <a:t>현재 이슈 및 검토 과제</a:t>
+              <a:t>현재 이슈 및 선배 피드백 반영 검토 과제</a:t>
             </a:r>
           </a:p>
         </p:txBody>
@@ -4802,7 +4818,7 @@
         <p:spPr>
           <a:xfrm>
             <a:off x="548640" y="1645920"/>
-            <a:ext cx="2633472" cy="3931920"/>
+            <a:ext cx="2633472" cy="4023360"/>
           </a:xfrm>
           <a:prstGeom prst="rect">
             <a:avLst/>
@@ -4889,7 +4905,7 @@
         </p:nvSpPr>
         <p:spPr>
           <a:xfrm>
-            <a:off x="749808" y="1874519"/>
+            <a:off x="749808" y="1847088"/>
             <a:ext cx="2231136" cy="411480"/>
           </a:xfrm>
           <a:prstGeom prst="rect">
@@ -4909,13 +4925,14 @@
               </a:spcAft>
             </a:pPr>
             <a:r>
-              <a:rPr sz="1700" b="1">
+              <a:rPr sz="1600" b="1">
                 <a:solidFill>
                   <a:srgbClr val="051C2C"/>
                 </a:solidFill>
                 <a:latin typeface="Malgun Gothic"/>
               </a:rPr>
-              <a:t>IPS 변동성 밴드 재검토</a:t>
+              <a:t>타깃 변동성 매칭
+(Vol Scaling)</a:t>
             </a:r>
           </a:p>
         </p:txBody>
@@ -4928,8 +4945,8 @@
         </p:nvSpPr>
         <p:spPr>
           <a:xfrm>
-            <a:off x="749808" y="2423160"/>
-            <a:ext cx="2231136" cy="3063239"/>
+            <a:off x="749808" y="2359152"/>
+            <a:ext cx="2231136" cy="3218688"/>
           </a:xfrm>
           <a:prstGeom prst="rect">
             <a:avLst/>
@@ -4944,49 +4961,49 @@
           <a:p>
             <a:pPr algn="l">
               <a:spcAft>
-                <a:spcPts val="700"/>
-              </a:spcAft>
-            </a:pPr>
-            <a:r>
-              <a:rPr sz="1300" b="0">
+                <a:spcPts val="600"/>
+              </a:spcAft>
+            </a:pPr>
+            <a:r>
+              <a:rPr sz="1200" b="0">
                 <a:solidFill>
                   <a:srgbClr val="475569"/>
                 </a:solidFill>
                 <a:latin typeface="Malgun Gothic"/>
               </a:rPr>
-              <a:t>·  기본 변동성 밴드 [8~12%]</a:t>
-            </a:r>
-          </a:p>
-          <a:p>
-            <a:pPr algn="l">
-              <a:spcAft>
-                <a:spcPts val="700"/>
-              </a:spcAft>
-            </a:pPr>
-            <a:r>
-              <a:rPr sz="1300" b="0">
+              <a:t>·  문제점: BL·위험균형 등 우수 모델의 변동성 하한(8%) 미달 탈락</a:t>
+            </a:r>
+          </a:p>
+          <a:p>
+            <a:pPr algn="l">
+              <a:spcAft>
+                <a:spcPts val="600"/>
+              </a:spcAft>
+            </a:pPr>
+            <a:r>
+              <a:rPr sz="1200" b="0">
                 <a:solidFill>
                   <a:srgbClr val="475569"/>
                 </a:solidFill>
                 <a:latin typeface="Malgun Gothic"/>
               </a:rPr>
-              <a:t>·  21개 모델 중 적격 2개뿐</a:t>
-            </a:r>
-          </a:p>
-          <a:p>
-            <a:pPr algn="l">
-              <a:spcAft>
-                <a:spcPts val="700"/>
-              </a:spcAft>
-            </a:pPr>
-            <a:r>
-              <a:rPr sz="1300" b="0">
+              <a:t>·  개선안: 현금/레버리지 조절로 목표 변동성(8~12%) 스케일링</a:t>
+            </a:r>
+          </a:p>
+          <a:p>
+            <a:pPr algn="l">
+              <a:spcAft>
+                <a:spcPts val="600"/>
+              </a:spcAft>
+            </a:pPr>
+            <a:r>
+              <a:rPr sz="1200" b="0">
                 <a:solidFill>
                   <a:srgbClr val="475569"/>
                 </a:solidFill>
                 <a:latin typeface="Malgun Gothic"/>
               </a:rPr>
-              <a:t>·  → 저변동성 우수 모델 배제 완화 검토</a:t>
+              <a:t>·  기대효과: 우수 알파 모델 복원 및 앙상블 다변화 극대화</a:t>
             </a:r>
           </a:p>
         </p:txBody>
@@ -5000,7 +5017,7 @@
         <p:spPr>
           <a:xfrm>
             <a:off x="3364992" y="1645920"/>
-            <a:ext cx="2633472" cy="3931920"/>
+            <a:ext cx="2633472" cy="4023360"/>
           </a:xfrm>
           <a:prstGeom prst="rect">
             <a:avLst/>
@@ -5087,7 +5104,7 @@
         </p:nvSpPr>
         <p:spPr>
           <a:xfrm>
-            <a:off x="3566160" y="1874519"/>
+            <a:off x="3566160" y="1847088"/>
             <a:ext cx="2231136" cy="411480"/>
           </a:xfrm>
           <a:prstGeom prst="rect">
@@ -5107,13 +5124,14 @@
               </a:spcAft>
             </a:pPr>
             <a:r>
-              <a:rPr sz="1700" b="1">
+              <a:rPr sz="1600" b="1">
                 <a:solidFill>
                   <a:srgbClr val="051C2C"/>
                 </a:solidFill>
                 <a:latin typeface="Malgun Gothic"/>
               </a:rPr>
-              <a:t>데이터 연속성 및 확장</a:t>
+              <a:t>실무 제약조건 추가
+(Turnover &amp; Cost)</a:t>
             </a:r>
           </a:p>
         </p:txBody>
@@ -5126,8 +5144,8 @@
         </p:nvSpPr>
         <p:spPr>
           <a:xfrm>
-            <a:off x="3566160" y="2423160"/>
-            <a:ext cx="2231136" cy="3063239"/>
+            <a:off x="3566160" y="2359152"/>
+            <a:ext cx="2231136" cy="3218688"/>
           </a:xfrm>
           <a:prstGeom prst="rect">
             <a:avLst/>
@@ -5142,49 +5160,49 @@
           <a:p>
             <a:pPr algn="l">
               <a:spcAft>
-                <a:spcPts val="700"/>
-              </a:spcAft>
-            </a:pPr>
-            <a:r>
-              <a:rPr sz="1300" b="0">
+                <a:spcPts val="600"/>
+              </a:spcAft>
+            </a:pPr>
+            <a:r>
+              <a:rPr sz="1200" b="0">
                 <a:solidFill>
                   <a:srgbClr val="475569"/>
                 </a:solidFill>
                 <a:latin typeface="Malgun Gothic"/>
               </a:rPr>
-              <a:t>·  현재: 18개 ETF 월간 수익률</a:t>
-            </a:r>
-          </a:p>
-          <a:p>
-            <a:pPr algn="l">
-              <a:spcAft>
-                <a:spcPts val="700"/>
-              </a:spcAft>
-            </a:pPr>
-            <a:r>
-              <a:rPr sz="1300" b="0">
+              <a:t>·  문제점: 정적 자산배분 가정으로 리밸런싱 마찰비용 미반영</a:t>
+            </a:r>
+          </a:p>
+          <a:p>
+            <a:pPr algn="l">
+              <a:spcAft>
+                <a:spcPts val="600"/>
+              </a:spcAft>
+            </a:pPr>
+            <a:r>
+              <a:rPr sz="1200" b="0">
                 <a:solidFill>
                   <a:srgbClr val="475569"/>
                 </a:solidFill>
                 <a:latin typeface="Malgun Gothic"/>
               </a:rPr>
-              <a:t>·  거시지표 주기 동기화 필요</a:t>
-            </a:r>
-          </a:p>
-          <a:p>
-            <a:pPr algn="l">
-              <a:spcAft>
-                <a:spcPts val="700"/>
-              </a:spcAft>
-            </a:pPr>
-            <a:r>
-              <a:rPr sz="1300" b="0">
+              <a:t>·  개선안: 연간 회전율(Turnover) 상한 및 슬리피지·수수료 모델링</a:t>
+            </a:r>
+          </a:p>
+          <a:p>
+            <a:pPr algn="l">
+              <a:spcAft>
+                <a:spcPts val="600"/>
+              </a:spcAft>
+            </a:pPr>
+            <a:r>
+              <a:rPr sz="1200" b="0">
                 <a:solidFill>
                   <a:srgbClr val="475569"/>
                 </a:solidFill>
                 <a:latin typeface="Malgun Gothic"/>
               </a:rPr>
-              <a:t>·  → 실시간 FRED API 연동</a:t>
+              <a:t>·  기대효과: 거래비용 차감 순수익률(Net Return) 기반 실무 검증</a:t>
             </a:r>
           </a:p>
         </p:txBody>
@@ -5198,7 +5216,7 @@
         <p:spPr>
           <a:xfrm>
             <a:off x="6181344" y="1645920"/>
-            <a:ext cx="2633472" cy="3931920"/>
+            <a:ext cx="2633472" cy="4023360"/>
           </a:xfrm>
           <a:prstGeom prst="rect">
             <a:avLst/>
@@ -5285,7 +5303,7 @@
         </p:nvSpPr>
         <p:spPr>
           <a:xfrm>
-            <a:off x="6382512" y="1874519"/>
+            <a:off x="6382512" y="1847088"/>
             <a:ext cx="2231136" cy="411480"/>
           </a:xfrm>
           <a:prstGeom prst="rect">
@@ -5305,13 +5323,14 @@
               </a:spcAft>
             </a:pPr>
             <a:r>
-              <a:rPr sz="1700" b="1">
+              <a:rPr sz="1600" b="1">
                 <a:solidFill>
                   <a:srgbClr val="051C2C"/>
                 </a:solidFill>
                 <a:latin typeface="Malgun Gothic"/>
               </a:rPr>
-              <a:t>LLM 실 API 추론 평가</a:t>
+              <a:t>원/달러 환헤지
+(FX Hedge) 모듈</a:t>
             </a:r>
           </a:p>
         </p:txBody>
@@ -5324,8 +5343,8 @@
         </p:nvSpPr>
         <p:spPr>
           <a:xfrm>
-            <a:off x="6382512" y="2423160"/>
-            <a:ext cx="2231136" cy="3063239"/>
+            <a:off x="6382512" y="2359152"/>
+            <a:ext cx="2231136" cy="3218688"/>
           </a:xfrm>
           <a:prstGeom prst="rect">
             <a:avLst/>
@@ -5340,49 +5359,49 @@
           <a:p>
             <a:pPr algn="l">
               <a:spcAft>
-                <a:spcPts val="700"/>
-              </a:spcAft>
-            </a:pPr>
-            <a:r>
-              <a:rPr sz="1300" b="0">
+                <a:spcPts val="600"/>
+              </a:spcAft>
+            </a:pPr>
+            <a:r>
+              <a:rPr sz="1200" b="0">
                 <a:solidFill>
                   <a:srgbClr val="475569"/>
                 </a:solidFill>
                 <a:latin typeface="Malgun Gothic"/>
               </a:rPr>
-              <a:t>·  현재: 시뮬레이션 + 템플릿 결합</a:t>
-            </a:r>
-          </a:p>
-          <a:p>
-            <a:pPr algn="l">
-              <a:spcAft>
-                <a:spcPts val="700"/>
-              </a:spcAft>
-            </a:pPr>
-            <a:r>
-              <a:rPr sz="1300" b="0">
+              <a:t>·  문제점: 해외 ETF(미 달러) 100% 노출에 따른 환율 위험 미통제</a:t>
+            </a:r>
+          </a:p>
+          <a:p>
+            <a:pPr algn="l">
+              <a:spcAft>
+                <a:spcPts val="600"/>
+              </a:spcAft>
+            </a:pPr>
+            <a:r>
+              <a:rPr sz="1200" b="0">
                 <a:solidFill>
                   <a:srgbClr val="475569"/>
                 </a:solidFill>
                 <a:latin typeface="Malgun Gothic"/>
               </a:rPr>
-              <a:t>·  실제 LLM 호출 시 비용·지연 발생</a:t>
-            </a:r>
-          </a:p>
-          <a:p>
-            <a:pPr algn="l">
-              <a:spcAft>
-                <a:spcPts val="700"/>
-              </a:spcAft>
-            </a:pPr>
-            <a:r>
-              <a:rPr sz="1300" b="0">
+              <a:t>·  개선안: 국내 연기금 가이드라인 기반 환헤지 비율(0~100%) 반영</a:t>
+            </a:r>
+          </a:p>
+          <a:p>
+            <a:pPr algn="l">
+              <a:spcAft>
+                <a:spcPts val="600"/>
+              </a:spcAft>
+            </a:pPr>
+            <a:r>
+              <a:rPr sz="1200" b="0">
                 <a:solidFill>
                   <a:srgbClr val="475569"/>
                 </a:solidFill>
                 <a:latin typeface="Malgun Gothic"/>
               </a:rPr>
-              <a:t>·  → 핵심 에이전트 선별 호출</a:t>
+              <a:t>·  기대효과: 환변동성 리스크 버퍼 구축 및 국내 기관 정합성 확보</a:t>
             </a:r>
           </a:p>
         </p:txBody>
@@ -5396,7 +5415,7 @@
         <p:spPr>
           <a:xfrm>
             <a:off x="8997696" y="1645920"/>
-            <a:ext cx="2633472" cy="3931920"/>
+            <a:ext cx="2633472" cy="4023360"/>
           </a:xfrm>
           <a:prstGeom prst="rect">
             <a:avLst/>
@@ -5483,7 +5502,7 @@
         </p:nvSpPr>
         <p:spPr>
           <a:xfrm>
-            <a:off x="9198864" y="1874519"/>
+            <a:off x="9198864" y="1847088"/>
             <a:ext cx="2231136" cy="411480"/>
           </a:xfrm>
           <a:prstGeom prst="rect">
@@ -5503,13 +5522,14 @@
               </a:spcAft>
             </a:pPr>
             <a:r>
-              <a:rPr sz="1700" b="1">
+              <a:rPr sz="1600" b="1">
                 <a:solidFill>
                   <a:srgbClr val="051C2C"/>
                 </a:solidFill>
                 <a:latin typeface="Malgun Gothic"/>
               </a:rPr>
-              <a:t>백테스트 강건성 분석</a:t>
+              <a:t>AI Co-Pilot 거버넌스
+포지셔닝 확립</a:t>
             </a:r>
           </a:p>
         </p:txBody>
@@ -5522,8 +5542,8 @@
         </p:nvSpPr>
         <p:spPr>
           <a:xfrm>
-            <a:off x="9198864" y="2423160"/>
-            <a:ext cx="2231136" cy="3063239"/>
+            <a:off x="9198864" y="2359152"/>
+            <a:ext cx="2231136" cy="3218688"/>
           </a:xfrm>
           <a:prstGeom prst="rect">
             <a:avLst/>
@@ -5538,49 +5558,49 @@
           <a:p>
             <a:pPr algn="l">
               <a:spcAft>
-                <a:spcPts val="700"/>
-              </a:spcAft>
-            </a:pPr>
-            <a:r>
-              <a:rPr sz="1300" b="0">
+                <a:spcPts val="600"/>
+              </a:spcAft>
+            </a:pPr>
+            <a:r>
+              <a:rPr sz="1200" b="0">
                 <a:solidFill>
                   <a:srgbClr val="475569"/>
                 </a:solidFill>
                 <a:latin typeface="Malgun Gothic"/>
               </a:rPr>
-              <a:t>·  단일 기간(2013-2026) 검증</a:t>
-            </a:r>
-          </a:p>
-          <a:p>
-            <a:pPr algn="l">
-              <a:spcAft>
-                <a:spcPts val="700"/>
-              </a:spcAft>
-            </a:pPr>
-            <a:r>
-              <a:rPr sz="1300" b="0">
+              <a:t>·  문제점: 완전 자율 운용으로 오인 시 연기금 수탁자 책임 저촉</a:t>
+            </a:r>
+          </a:p>
+          <a:p>
+            <a:pPr algn="l">
+              <a:spcAft>
+                <a:spcPts val="600"/>
+              </a:spcAft>
+            </a:pPr>
+            <a:r>
+              <a:rPr sz="1200" b="0">
                 <a:solidFill>
                   <a:srgbClr val="475569"/>
                 </a:solidFill>
                 <a:latin typeface="Malgun Gothic"/>
               </a:rPr>
-              <a:t>·  거래비용·슬리피지 미반영</a:t>
-            </a:r>
-          </a:p>
-          <a:p>
-            <a:pPr algn="l">
-              <a:spcAft>
-                <a:spcPts val="700"/>
-              </a:spcAft>
-            </a:pPr>
-            <a:r>
-              <a:rPr sz="1300" b="0">
+              <a:t>·  개선안: 투자위원회 시나리오 분석 및 SAA 의사결정 보좌 DSS</a:t>
+            </a:r>
+          </a:p>
+          <a:p>
+            <a:pPr algn="l">
+              <a:spcAft>
+                <a:spcPts val="600"/>
+              </a:spcAft>
+            </a:pPr>
+            <a:r>
+              <a:rPr sz="1200" b="0">
                 <a:solidFill>
                   <a:srgbClr val="475569"/>
                 </a:solidFill>
                 <a:latin typeface="Malgun Gothic"/>
               </a:rPr>
-              <a:t>·  → 서브 구간별 안정성 검증</a:t>
+              <a:t>·  기대효과: 인간 위원회와 협업하는 현실적 거버넌스 모델 확립</a:t>
             </a:r>
           </a:p>
         </p:txBody>
@@ -5720,7 +5740,7 @@
                 </a:solidFill>
                 <a:latin typeface="Malgun Gothic"/>
               </a:rPr>
-              <a:t>기말까지 로드맵</a:t>
+              <a:t>선배 피드백을 반영한 기말 로드맵</a:t>
             </a:r>
           </a:p>
         </p:txBody>
@@ -5983,7 +6003,7 @@
         <p:spPr>
           <a:xfrm>
             <a:off x="548640" y="2651760"/>
-            <a:ext cx="2633472" cy="2743200"/>
+            <a:ext cx="2633472" cy="2926080"/>
           </a:xfrm>
           <a:prstGeom prst="rect">
             <a:avLst/>
@@ -6026,8 +6046,8 @@
         </p:nvSpPr>
         <p:spPr>
           <a:xfrm>
-            <a:off x="777240" y="2880360"/>
-            <a:ext cx="2194560" cy="457200"/>
+            <a:off x="777240" y="2852928"/>
+            <a:ext cx="2194560" cy="502920"/>
           </a:xfrm>
           <a:prstGeom prst="rect">
             <a:avLst/>
@@ -6046,13 +6066,13 @@
               </a:spcAft>
             </a:pPr>
             <a:r>
-              <a:rPr sz="2000" b="1">
+              <a:rPr sz="1700" b="1">
                 <a:solidFill>
                   <a:srgbClr val="051C2C"/>
                 </a:solidFill>
                 <a:latin typeface="Malgun Gothic"/>
               </a:rPr>
-              <a:t>통합 및 안정화</a:t>
+              <a:t>변동성 매칭 &amp; 모델 고도화</a:t>
             </a:r>
           </a:p>
         </p:txBody>
@@ -6065,8 +6085,8 @@
         </p:nvSpPr>
         <p:spPr>
           <a:xfrm>
-            <a:off x="777240" y="3566160"/>
-            <a:ext cx="2240280" cy="1828800"/>
+            <a:off x="777240" y="3474720"/>
+            <a:ext cx="2240280" cy="2011680"/>
           </a:xfrm>
           <a:prstGeom prst="rect">
             <a:avLst/>
@@ -6081,49 +6101,49 @@
           <a:p>
             <a:pPr algn="l">
               <a:spcAft>
-                <a:spcPts val="1200"/>
-              </a:spcAft>
-            </a:pPr>
-            <a:r>
-              <a:rPr sz="1400" b="0">
+                <a:spcPts val="1000"/>
+              </a:spcAft>
+            </a:pPr>
+            <a:r>
+              <a:rPr sz="1300" b="0">
                 <a:solidFill>
                   <a:srgbClr val="475569"/>
                 </a:solidFill>
                 <a:latin typeface="Malgun Gothic"/>
               </a:rPr>
-              <a:t>·  팀원 PR 병합 완료</a:t>
-            </a:r>
-          </a:p>
-          <a:p>
-            <a:pPr algn="l">
-              <a:spcAft>
-                <a:spcPts val="1200"/>
-              </a:spcAft>
-            </a:pPr>
-            <a:r>
-              <a:rPr sz="1400" b="0">
+              <a:t>·  타깃 변동성 매칭(Vol Scaling) 구현</a:t>
+            </a:r>
+          </a:p>
+          <a:p>
+            <a:pPr algn="l">
+              <a:spcAft>
+                <a:spcPts val="1000"/>
+              </a:spcAft>
+            </a:pPr>
+            <a:r>
+              <a:rPr sz="1300" b="0">
                 <a:solidFill>
                   <a:srgbClr val="475569"/>
                 </a:solidFill>
                 <a:latin typeface="Malgun Gothic"/>
               </a:rPr>
-              <a:t>·  IPS 밴드 파라미터 튜닝</a:t>
-            </a:r>
-          </a:p>
-          <a:p>
-            <a:pPr algn="l">
-              <a:spcAft>
-                <a:spcPts val="1200"/>
-              </a:spcAft>
-            </a:pPr>
-            <a:r>
-              <a:rPr sz="1400" b="0">
+              <a:t>·  블랙-리터만 · 위험균형 모델 적격 통과</a:t>
+            </a:r>
+          </a:p>
+          <a:p>
+            <a:pPr algn="l">
+              <a:spcAft>
+                <a:spcPts val="1000"/>
+              </a:spcAft>
+            </a:pPr>
+            <a:r>
+              <a:rPr sz="1300" b="0">
                 <a:solidFill>
                   <a:srgbClr val="475569"/>
                 </a:solidFill>
                 <a:latin typeface="Malgun Gothic"/>
               </a:rPr>
-              <a:t>·  배포 도메인 단일화</a:t>
+              <a:t>·  21개 최적화 모델 파이프라인 수치 안정화</a:t>
             </a:r>
           </a:p>
         </p:txBody>
@@ -6259,7 +6279,7 @@
         <p:spPr>
           <a:xfrm>
             <a:off x="3364992" y="2651760"/>
-            <a:ext cx="2633472" cy="2743200"/>
+            <a:ext cx="2633472" cy="2926080"/>
           </a:xfrm>
           <a:prstGeom prst="rect">
             <a:avLst/>
@@ -6302,8 +6322,8 @@
         </p:nvSpPr>
         <p:spPr>
           <a:xfrm>
-            <a:off x="3593592" y="2880360"/>
-            <a:ext cx="2194560" cy="457200"/>
+            <a:off x="3593592" y="2852928"/>
+            <a:ext cx="2194560" cy="502920"/>
           </a:xfrm>
           <a:prstGeom prst="rect">
             <a:avLst/>
@@ -6322,13 +6342,13 @@
               </a:spcAft>
             </a:pPr>
             <a:r>
-              <a:rPr sz="2000" b="1">
+              <a:rPr sz="1700" b="1">
                 <a:solidFill>
                   <a:srgbClr val="051C2C"/>
                 </a:solidFill>
                 <a:latin typeface="Malgun Gothic"/>
               </a:rPr>
-              <a:t>데이터 고도화</a:t>
+              <a:t>기관 실무 제약조건 반영</a:t>
             </a:r>
           </a:p>
         </p:txBody>
@@ -6341,8 +6361,8 @@
         </p:nvSpPr>
         <p:spPr>
           <a:xfrm>
-            <a:off x="3593592" y="3566160"/>
-            <a:ext cx="2240280" cy="1828800"/>
+            <a:off x="3593592" y="3474720"/>
+            <a:ext cx="2240280" cy="2011680"/>
           </a:xfrm>
           <a:prstGeom prst="rect">
             <a:avLst/>
@@ -6357,49 +6377,49 @@
           <a:p>
             <a:pPr algn="l">
               <a:spcAft>
-                <a:spcPts val="1200"/>
-              </a:spcAft>
-            </a:pPr>
-            <a:r>
-              <a:rPr sz="1400" b="0">
+                <a:spcPts val="1000"/>
+              </a:spcAft>
+            </a:pPr>
+            <a:r>
+              <a:rPr sz="1300" b="0">
                 <a:solidFill>
                   <a:srgbClr val="475569"/>
                 </a:solidFill>
                 <a:latin typeface="Malgun Gothic"/>
               </a:rPr>
-              <a:t>·  FRED 거시지표 API 연동</a:t>
-            </a:r>
-          </a:p>
-          <a:p>
-            <a:pPr algn="l">
-              <a:spcAft>
-                <a:spcPts val="1200"/>
-              </a:spcAft>
-            </a:pPr>
-            <a:r>
-              <a:rPr sz="1400" b="0">
+              <a:t>·  원/달러 환헤지(FX Hedge) 룰 엔진 개발</a:t>
+            </a:r>
+          </a:p>
+          <a:p>
+            <a:pPr algn="l">
+              <a:spcAft>
+                <a:spcPts val="1000"/>
+              </a:spcAft>
+            </a:pPr>
+            <a:r>
+              <a:rPr sz="1300" b="0">
                 <a:solidFill>
                   <a:srgbClr val="475569"/>
                 </a:solidFill>
                 <a:latin typeface="Malgun Gothic"/>
               </a:rPr>
-              <a:t>·  18개 ETF 공분산 재추정</a:t>
-            </a:r>
-          </a:p>
-          <a:p>
-            <a:pPr algn="l">
-              <a:spcAft>
-                <a:spcPts val="1200"/>
-              </a:spcAft>
-            </a:pPr>
-            <a:r>
-              <a:rPr sz="1400" b="0">
+              <a:t>·  회전율(Turnover) 제약식 및 거래비용 반영</a:t>
+            </a:r>
+          </a:p>
+          <a:p>
+            <a:pPr algn="l">
+              <a:spcAft>
+                <a:spcPts val="1000"/>
+              </a:spcAft>
+            </a:pPr>
+            <a:r>
+              <a:rPr sz="1300" b="0">
                 <a:solidFill>
                   <a:srgbClr val="475569"/>
                 </a:solidFill>
                 <a:latin typeface="Malgun Gothic"/>
               </a:rPr>
-              <a:t>·  자산 유니버스 확장 검토</a:t>
+              <a:t>·  FRED 거시지표 API 실시간 동기화</a:t>
             </a:r>
           </a:p>
         </p:txBody>
@@ -6535,7 +6555,7 @@
         <p:spPr>
           <a:xfrm>
             <a:off x="6181344" y="2651760"/>
-            <a:ext cx="2633472" cy="2743200"/>
+            <a:ext cx="2633472" cy="2926080"/>
           </a:xfrm>
           <a:prstGeom prst="rect">
             <a:avLst/>
@@ -6578,8 +6598,8 @@
         </p:nvSpPr>
         <p:spPr>
           <a:xfrm>
-            <a:off x="6409944" y="2880360"/>
-            <a:ext cx="2194560" cy="457200"/>
+            <a:off x="6409944" y="2852928"/>
+            <a:ext cx="2194560" cy="502920"/>
           </a:xfrm>
           <a:prstGeom prst="rect">
             <a:avLst/>
@@ -6598,13 +6618,13 @@
               </a:spcAft>
             </a:pPr>
             <a:r>
-              <a:rPr sz="2000" b="1">
+              <a:rPr sz="1700" b="1">
                 <a:solidFill>
                   <a:srgbClr val="051C2C"/>
                 </a:solidFill>
                 <a:latin typeface="Malgun Gothic"/>
               </a:rPr>
-              <a:t>LLM 실연동 검증</a:t>
+              <a:t>LLM Co-Pilot 실연동</a:t>
             </a:r>
           </a:p>
         </p:txBody>
@@ -6617,8 +6637,8 @@
         </p:nvSpPr>
         <p:spPr>
           <a:xfrm>
-            <a:off x="6409944" y="3566160"/>
-            <a:ext cx="2240280" cy="1828800"/>
+            <a:off x="6409944" y="3474720"/>
+            <a:ext cx="2240280" cy="2011680"/>
           </a:xfrm>
           <a:prstGeom prst="rect">
             <a:avLst/>
@@ -6633,49 +6653,49 @@
           <a:p>
             <a:pPr algn="l">
               <a:spcAft>
-                <a:spcPts val="1200"/>
-              </a:spcAft>
-            </a:pPr>
-            <a:r>
-              <a:rPr sz="1400" b="0">
+                <a:spcPts val="1000"/>
+              </a:spcAft>
+            </a:pPr>
+            <a:r>
+              <a:rPr sz="1300" b="0">
                 <a:solidFill>
                   <a:srgbClr val="475569"/>
                 </a:solidFill>
                 <a:latin typeface="Malgun Gothic"/>
               </a:rPr>
-              <a:t>·  거시 · CIO 실 API 연동</a:t>
-            </a:r>
-          </a:p>
-          <a:p>
-            <a:pPr algn="l">
-              <a:spcAft>
-                <a:spcPts val="1200"/>
-              </a:spcAft>
-            </a:pPr>
-            <a:r>
-              <a:rPr sz="1400" b="0">
+              <a:t>·  거시 · CIO 실 LLM API(Gemini/Claude) 연동</a:t>
+            </a:r>
+          </a:p>
+          <a:p>
+            <a:pPr algn="l">
+              <a:spcAft>
+                <a:spcPts val="1000"/>
+              </a:spcAft>
+            </a:pPr>
+            <a:r>
+              <a:rPr sz="1300" b="0">
                 <a:solidFill>
                   <a:srgbClr val="475569"/>
                 </a:solidFill>
                 <a:latin typeface="Malgun Gothic"/>
               </a:rPr>
-              <a:t>·  에이전트 추론 정성 평가</a:t>
-            </a:r>
-          </a:p>
-          <a:p>
-            <a:pPr algn="l">
-              <a:spcAft>
-                <a:spcPts val="1200"/>
-              </a:spcAft>
-            </a:pPr>
-            <a:r>
-              <a:rPr sz="1400" b="0">
+              <a:t>·  투자위원회 안건 및 시나리오 메모 자동 생성</a:t>
+            </a:r>
+          </a:p>
+          <a:p>
+            <a:pPr algn="l">
+              <a:spcAft>
+                <a:spcPts val="1000"/>
+              </a:spcAft>
+            </a:pPr>
+            <a:r>
+              <a:rPr sz="1300" b="0">
                 <a:solidFill>
                   <a:srgbClr val="475569"/>
                 </a:solidFill>
                 <a:latin typeface="Malgun Gothic"/>
               </a:rPr>
-              <a:t>·  시뮬레이션 모드와 비교</a:t>
+              <a:t>·  인간 위원회-AI Co-Pilot 협업 워크플로우</a:t>
             </a:r>
           </a:p>
         </p:txBody>
@@ -6811,7 +6831,7 @@
         <p:spPr>
           <a:xfrm>
             <a:off x="8997696" y="2651760"/>
-            <a:ext cx="2633472" cy="2743200"/>
+            <a:ext cx="2633472" cy="2926080"/>
           </a:xfrm>
           <a:prstGeom prst="rect">
             <a:avLst/>
@@ -6854,8 +6874,8 @@
         </p:nvSpPr>
         <p:spPr>
           <a:xfrm>
-            <a:off x="9226296" y="2880360"/>
-            <a:ext cx="2194560" cy="457200"/>
+            <a:off x="9226296" y="2852928"/>
+            <a:ext cx="2194560" cy="502920"/>
           </a:xfrm>
           <a:prstGeom prst="rect">
             <a:avLst/>
@@ -6874,13 +6894,13 @@
               </a:spcAft>
             </a:pPr>
             <a:r>
-              <a:rPr sz="2000" b="1">
+              <a:rPr sz="1700" b="1">
                 <a:solidFill>
                   <a:srgbClr val="051C2C"/>
                 </a:solidFill>
                 <a:latin typeface="Malgun Gothic"/>
               </a:rPr>
-              <a:t>최종 검증 및 보고</a:t>
+              <a:t>실증 백테스트 &amp; 최종 보고</a:t>
             </a:r>
           </a:p>
         </p:txBody>
@@ -6893,8 +6913,8 @@
         </p:nvSpPr>
         <p:spPr>
           <a:xfrm>
-            <a:off x="9226296" y="3566160"/>
-            <a:ext cx="2240280" cy="1828800"/>
+            <a:off x="9226296" y="3474720"/>
+            <a:ext cx="2240280" cy="2011680"/>
           </a:xfrm>
           <a:prstGeom prst="rect">
             <a:avLst/>
@@ -6909,49 +6929,49 @@
           <a:p>
             <a:pPr algn="l">
               <a:spcAft>
-                <a:spcPts val="1200"/>
-              </a:spcAft>
-            </a:pPr>
-            <a:r>
-              <a:rPr sz="1400" b="0">
+                <a:spcPts val="1000"/>
+              </a:spcAft>
+            </a:pPr>
+            <a:r>
+              <a:rPr sz="1300" b="0">
                 <a:solidFill>
                   <a:srgbClr val="475569"/>
                 </a:solidFill>
                 <a:latin typeface="Malgun Gothic"/>
               </a:rPr>
-              <a:t>·  거래비용 반영 백테스트</a:t>
-            </a:r>
-          </a:p>
-          <a:p>
-            <a:pPr algn="l">
-              <a:spcAft>
-                <a:spcPts val="1200"/>
-              </a:spcAft>
-            </a:pPr>
-            <a:r>
-              <a:rPr sz="1400" b="0">
+              <a:t>·  거래비용 반영 순수익률 다구간 백테스트</a:t>
+            </a:r>
+          </a:p>
+          <a:p>
+            <a:pPr algn="l">
+              <a:spcAft>
+                <a:spcPts val="1000"/>
+              </a:spcAft>
+            </a:pPr>
+            <a:r>
+              <a:rPr sz="1300" b="0">
                 <a:solidFill>
                   <a:srgbClr val="475569"/>
                 </a:solidFill>
                 <a:latin typeface="Malgun Gothic"/>
               </a:rPr>
-              <a:t>·  60/40 · 동일가중 심층 비교</a:t>
-            </a:r>
-          </a:p>
-          <a:p>
-            <a:pPr algn="l">
-              <a:spcAft>
-                <a:spcPts val="1200"/>
-              </a:spcAft>
-            </a:pPr>
-            <a:r>
-              <a:rPr sz="1400" b="0">
+              <a:t>·  60/40 및 단일 모델 대비 샤프·MDD 심층 비교</a:t>
+            </a:r>
+          </a:p>
+          <a:p>
+            <a:pPr algn="l">
+              <a:spcAft>
+                <a:spcPts val="1000"/>
+              </a:spcAft>
+            </a:pPr>
+            <a:r>
+              <a:rPr sz="1300" b="0">
                 <a:solidFill>
                   <a:srgbClr val="475569"/>
                 </a:solidFill>
                 <a:latin typeface="Malgun Gothic"/>
               </a:rPr>
-              <a:t>·  기말 보고서 및 발표 준비</a:t>
+              <a:t>·  기말 종합 보고서 및 최종 시연 발표</a:t>
             </a:r>
           </a:p>
         </p:txBody>
@@ -6964,7 +6984,7 @@
         </p:nvSpPr>
         <p:spPr>
           <a:xfrm>
-            <a:off x="548640" y="5989320"/>
+            <a:off x="548640" y="6035040"/>
             <a:ext cx="10972800" cy="365760"/>
           </a:xfrm>
           <a:prstGeom prst="rect">
@@ -6984,13 +7004,13 @@
               </a:spcAft>
             </a:pPr>
             <a:r>
-              <a:rPr sz="1100" b="0">
+              <a:rPr sz="1150" b="0">
                 <a:solidFill>
                   <a:srgbClr val="94A3B8"/>
                 </a:solidFill>
                 <a:latin typeface="Malgun Gothic"/>
               </a:rPr>
-              <a:t>※ 주차는 중간발표 이후 기준 일정</a:t>
+              <a:t>※ 선배 피드백 3대 권고사항(Vol Scaling, 기관 제약조건, Co-Pilot 확립)을 일정 전반에 전면 반영</a:t>
             </a:r>
           </a:p>
         </p:txBody>
@@ -7314,7 +7334,7 @@
         </p:nvSpPr>
         <p:spPr>
           <a:xfrm>
-            <a:off x="914400" y="1920240"/>
+            <a:off x="914400" y="1901952"/>
             <a:ext cx="4846320" cy="457200"/>
           </a:xfrm>
           <a:prstGeom prst="rect">
@@ -7334,13 +7354,13 @@
               </a:spcAft>
             </a:pPr>
             <a:r>
-              <a:rPr sz="2000" b="1">
+              <a:rPr sz="1900" b="1">
                 <a:solidFill>
                   <a:srgbClr val="051C2C"/>
                 </a:solidFill>
                 <a:latin typeface="Malgun Gothic"/>
               </a:rPr>
-              <a:t>완성형 자율 SAA 시스템</a:t>
+              <a:t>투자위원회 지원 AI Co-Pilot 웹 시스템</a:t>
             </a:r>
           </a:p>
         </p:txBody>
@@ -7354,7 +7374,7 @@
         <p:spPr>
           <a:xfrm>
             <a:off x="914400" y="2423160"/>
-            <a:ext cx="4846320" cy="365760"/>
+            <a:ext cx="4846320" cy="411480"/>
           </a:xfrm>
           <a:prstGeom prst="rect">
             <a:avLst/>
@@ -7373,13 +7393,13 @@
               </a:spcAft>
             </a:pPr>
             <a:r>
-              <a:rPr sz="1400" b="0">
+              <a:rPr sz="1350" b="0">
                 <a:solidFill>
                   <a:srgbClr val="475569"/>
                 </a:solidFill>
                 <a:latin typeface="Malgun Gothic"/>
               </a:rPr>
-              <a:t>실데이터 · 실 API 연동 및 고도화 완료</a:t>
+              <a:t>인간 CIO 의사결정을 보좌하는 L3 수준 자율 SAA/DAA 플랫폼 완성</a:t>
             </a:r>
           </a:p>
         </p:txBody>
@@ -7480,7 +7500,7 @@
         </p:nvSpPr>
         <p:spPr>
           <a:xfrm>
-            <a:off x="6537960" y="1920240"/>
+            <a:off x="6537960" y="1901952"/>
             <a:ext cx="4846320" cy="457200"/>
           </a:xfrm>
           <a:prstGeom prst="rect">
@@ -7500,13 +7520,13 @@
               </a:spcAft>
             </a:pPr>
             <a:r>
-              <a:rPr sz="2000" b="1">
+              <a:rPr sz="1900" b="1">
                 <a:solidFill>
                   <a:srgbClr val="051C2C"/>
                 </a:solidFill>
                 <a:latin typeface="Malgun Gothic"/>
               </a:rPr>
-              <a:t>24/7 글로벌 라이브 데모</a:t>
+              <a:t>환헤지 · 거래비용 반영 기관급 수리 엔진</a:t>
             </a:r>
           </a:p>
         </p:txBody>
@@ -7520,7 +7540,7 @@
         <p:spPr>
           <a:xfrm>
             <a:off x="6537960" y="2423160"/>
-            <a:ext cx="4846320" cy="365760"/>
+            <a:ext cx="4846320" cy="411480"/>
           </a:xfrm>
           <a:prstGeom prst="rect">
             <a:avLst/>
@@ -7539,13 +7559,13 @@
               </a:spcAft>
             </a:pPr>
             <a:r>
-              <a:rPr sz="1400" b="0">
+              <a:rPr sz="1350" b="0">
                 <a:solidFill>
                   <a:srgbClr val="475569"/>
                 </a:solidFill>
                 <a:latin typeface="Malgun Gothic"/>
               </a:rPr>
-              <a:t>Render 클라우드 상시 운영 (onrender.com)</a:t>
+              <a:t>21개 모델 수리 최적화 + Vol Scaling + 회전율/비용 제약 완비</a:t>
             </a:r>
           </a:p>
         </p:txBody>
@@ -7646,7 +7666,7 @@
         </p:nvSpPr>
         <p:spPr>
           <a:xfrm>
-            <a:off x="914400" y="3520439"/>
+            <a:off x="914400" y="3502152"/>
             <a:ext cx="4846320" cy="457200"/>
           </a:xfrm>
           <a:prstGeom prst="rect">
@@ -7666,13 +7686,13 @@
               </a:spcAft>
             </a:pPr>
             <a:r>
-              <a:rPr sz="2000" b="1">
+              <a:rPr sz="1900" b="1">
                 <a:solidFill>
                   <a:srgbClr val="051C2C"/>
                 </a:solidFill>
                 <a:latin typeface="Malgun Gothic"/>
               </a:rPr>
-              <a:t>심층 실증 분석 보고서</a:t>
+              <a:t>24/7 글로벌 라이브 데모 &amp; API</a:t>
             </a:r>
           </a:p>
         </p:txBody>
@@ -7686,7 +7706,7 @@
         <p:spPr>
           <a:xfrm>
             <a:off x="914400" y="4023359"/>
-            <a:ext cx="4846320" cy="365760"/>
+            <a:ext cx="4846320" cy="411480"/>
           </a:xfrm>
           <a:prstGeom prst="rect">
             <a:avLst/>
@@ -7705,13 +7725,13 @@
               </a:spcAft>
             </a:pPr>
             <a:r>
-              <a:rPr sz="1400" b="0">
+              <a:rPr sz="1350" b="0">
                 <a:solidFill>
                   <a:srgbClr val="475569"/>
                 </a:solidFill>
                 <a:latin typeface="Malgun Gothic"/>
               </a:rPr>
-              <a:t>시장 국면별 백테스트 및 벤치마크 대비 우수성 입증</a:t>
+              <a:t>Render 클라우드 상시 운영 및 외부 연동 API 문서화 (onrender.com)</a:t>
             </a:r>
           </a:p>
         </p:txBody>
@@ -7812,7 +7832,7 @@
         </p:nvSpPr>
         <p:spPr>
           <a:xfrm>
-            <a:off x="6537960" y="3520439"/>
+            <a:off x="6537960" y="3502152"/>
             <a:ext cx="4846320" cy="457200"/>
           </a:xfrm>
           <a:prstGeom prst="rect">
@@ -7832,13 +7852,13 @@
               </a:spcAft>
             </a:pPr>
             <a:r>
-              <a:rPr sz="2000" b="1">
+              <a:rPr sz="1900" b="1">
                 <a:solidFill>
                   <a:srgbClr val="051C2C"/>
                 </a:solidFill>
                 <a:latin typeface="Malgun Gothic"/>
               </a:rPr>
-              <a:t>코드베이스 및 문서화</a:t>
+              <a:t>국면별 실증 분석 보고서 및 오픈소스</a:t>
             </a:r>
           </a:p>
         </p:txBody>
@@ -7852,7 +7872,7 @@
         <p:spPr>
           <a:xfrm>
             <a:off x="6537960" y="4023359"/>
-            <a:ext cx="4846320" cy="365760"/>
+            <a:ext cx="4846320" cy="411480"/>
           </a:xfrm>
           <a:prstGeom prst="rect">
             <a:avLst/>
@@ -7871,13 +7891,13 @@
               </a:spcAft>
             </a:pPr>
             <a:r>
-              <a:rPr sz="1400" b="0">
+              <a:rPr sz="1350" b="0">
                 <a:solidFill>
                   <a:srgbClr val="475569"/>
                 </a:solidFill>
                 <a:latin typeface="Malgun Gothic"/>
               </a:rPr>
-              <a:t>GitHub 저장소 완비 및 상세 아키텍처 가이드</a:t>
+              <a:t>장기 백테스트 실증 성과 입증 및 GitHub 완전 오픈소스 가이드 제공</a:t>
             </a:r>
           </a:p>
         </p:txBody>
@@ -8261,7 +8281,7 @@
                 </a:solidFill>
                 <a:latin typeface="Malgun Gothic"/>
               </a:rPr>
-              <a:t>논문 배경</a:t>
+              <a:t>논문 배경 및 포지셔닝</a:t>
             </a:r>
           </a:p>
         </p:txBody>
@@ -8300,7 +8320,7 @@
                 </a:solidFill>
                 <a:latin typeface="Malgun Gothic"/>
               </a:rPr>
-              <a:t>기관 SAA의 구조적 한계 · 6단계 파이프라인 · 4대 설계 원칙</a:t>
+              <a:t>기관 SAA 구조적 한계 · 6단계 파이프라인 · AI Co-Pilot 정의</a:t>
             </a:r>
           </a:p>
         </p:txBody>
@@ -8461,7 +8481,7 @@
                 </a:solidFill>
                 <a:latin typeface="Malgun Gothic"/>
               </a:rPr>
-              <a:t>시의성 · 실무성 · 구현 가능성</a:t>
+              <a:t>시의성 · 실무 거버넌스 부합성 · 구현 및 검증 가능성</a:t>
             </a:r>
           </a:p>
         </p:txBody>
@@ -8622,7 +8642,7 @@
                 </a:solidFill>
                 <a:latin typeface="Malgun Gothic"/>
               </a:rPr>
-              <a:t>메인 대시보드 · 자산 배분 · 18개 ETF 포트폴리오 · 보르다 투표</a:t>
+              <a:t>159개월 실데이터 · 21개 모델 후보군 · 4대 실화면 심층 분석</a:t>
             </a:r>
           </a:p>
         </p:txBody>
@@ -8744,7 +8764,7 @@
                 </a:solidFill>
                 <a:latin typeface="Malgun Gothic"/>
               </a:rPr>
-              <a:t>중간 성과 및 향후 계획</a:t>
+              <a:t>중간 성과 및 향후 로드맵</a:t>
             </a:r>
           </a:p>
         </p:txBody>
@@ -8783,7 +8803,7 @@
                 </a:solidFill>
                 <a:latin typeface="Malgun Gothic"/>
               </a:rPr>
-              <a:t>진행 현황 · 주요 이슈 · 기말까지 로드맵</a:t>
+              <a:t>타깃 변동성 매칭(Vol Scaling) · 실무 제약조건 · 기말 계획</a:t>
             </a:r>
           </a:p>
         </p:txBody>
@@ -8923,7 +8943,7 @@
                 </a:solidFill>
                 <a:latin typeface="Malgun Gothic"/>
               </a:rPr>
-              <a:t>기관 SAA의 구조적 한계</a:t>
+              <a:t>기관 SAA의 구조적 한계 및 Co-Pilot 필요성</a:t>
             </a:r>
           </a:p>
         </p:txBody>
@@ -9791,13 +9811,13 @@
               </a:spcAft>
             </a:pPr>
             <a:r>
-              <a:rPr sz="1800" b="1">
+              <a:rPr sz="1700" b="1">
                 <a:solidFill>
                   <a:srgbClr val="FFFFFF"/>
                 </a:solidFill>
                 <a:latin typeface="Malgun Gothic"/>
               </a:rPr>
-              <a:t>논문 제안  →  약 50개 AI 에이전트가 SAA 전 과정을 분업 · 상호 검증 · 감사 기록</a:t>
+              <a:t>핵심 정의  →  인간 CIO 대체가 아닌, 투자위원회의 시나리오 분석 및 SAA 의사결정을 보좌하는 AI Co-Pilot</a:t>
             </a:r>
           </a:p>
         </p:txBody>
@@ -9937,7 +9957,7 @@
                 </a:solidFill>
                 <a:latin typeface="Malgun Gothic"/>
               </a:rPr>
-              <a:t>6단계 에이전트 파이프라인</a:t>
+              <a:t>6단계 에이전트 파이프라인 아키텍처</a:t>
             </a:r>
           </a:p>
         </p:txBody>
@@ -10220,7 +10240,7 @@
                 </a:solidFill>
                 <a:latin typeface="Malgun Gothic"/>
               </a:rPr>
-              <a:t>후기 사이클 진단</a:t>
+              <a:t>성장·물가 4분면 진단</a:t>
             </a:r>
           </a:p>
         </p:txBody>
@@ -10820,7 +10840,7 @@
                 </a:solidFill>
                 <a:latin typeface="Malgun Gothic"/>
               </a:rPr>
-              <a:t>21개 최적화 모델 경쟁</a:t>
+              <a:t>4개 계열 21개 모델 경쟁</a:t>
             </a:r>
           </a:p>
         </p:txBody>
@@ -11344,7 +11364,7 @@
                 </a:solidFill>
                 <a:latin typeface="Malgun Gothic"/>
               </a:rPr>
-              <a:t>입력: 18개 자산군 시계열 · 거시지표   |   출력: 최종 SAA 비중 · 이사회 메모</a:t>
+              <a:t>입력: 18개 ETF 실데이터 159개월 · 거시지표   |   출력: 최종 권고 비중 · 투자위원회 안건 메모</a:t>
             </a:r>
           </a:p>
         </p:txBody>
@@ -11484,7 +11504,7 @@
                 </a:solidFill>
                 <a:latin typeface="Malgun Gothic"/>
               </a:rPr>
-              <a:t>4대 설계 원칙</a:t>
+              <a:t>기관 거버넌스를 위한 4대 설계 원칙</a:t>
             </a:r>
           </a:p>
         </p:txBody>
@@ -12055,7 +12075,7 @@
                 </a:solidFill>
                 <a:latin typeface="Malgun Gothic"/>
               </a:rPr>
-              <a:t>LLM = 정성적 해석 · 토론</a:t>
+              <a:t>LLM = 정성 해석 · 위원회 토론</a:t>
             </a:r>
           </a:p>
           <a:p>
@@ -12071,7 +12091,7 @@
                 </a:solidFill>
                 <a:latin typeface="Malgun Gothic"/>
               </a:rPr>
-              <a:t>Python = 수학 행렬 계산</a:t>
+              <a:t>Python = 수학 행렬 계산 (환각 0%)</a:t>
             </a:r>
           </a:p>
         </p:txBody>
@@ -12315,7 +12335,7 @@
                 </a:solidFill>
                 <a:latin typeface="Malgun Gothic"/>
               </a:rPr>
-              <a:t>CRO 거부권(Veto) → 미달 시 배제</a:t>
+              <a:t>CRO 거부권(Veto) → IPS 미달 배제</a:t>
             </a:r>
           </a:p>
         </p:txBody>
@@ -12559,7 +12579,7 @@
                 </a:solidFill>
                 <a:latin typeface="Malgun Gothic"/>
               </a:rPr>
-              <a:t>보르다 투표 · 소수의견 · 조정 사유 기록</a:t>
+              <a:t>보르다 투표 · 소수의견 · 심의 사유 기록</a:t>
             </a:r>
           </a:p>
         </p:txBody>
@@ -12598,7 +12618,7 @@
                 </a:solidFill>
                 <a:latin typeface="Malgun Gothic"/>
               </a:rPr>
-              <a:t>핵심  →  LLM 수치 환각 차단 (Tool Determinism) + 의사결정 투명성</a:t>
+              <a:t>핵심  →  LLM 수치 환각 원천 차단 (Tool Determinism) + 투명한 이사회 감사 추적성</a:t>
             </a:r>
           </a:p>
         </p:txBody>
@@ -12738,7 +12758,7 @@
                 </a:solidFill>
                 <a:latin typeface="Malgun Gothic"/>
               </a:rPr>
-              <a:t>왜 이 논문인가</a:t>
+              <a:t>왜 이 논문인가: 학술 연구에서 실무 시스템으로</a:t>
             </a:r>
           </a:p>
         </p:txBody>
@@ -12922,7 +12942,7 @@
         </p:nvSpPr>
         <p:spPr>
           <a:xfrm>
-            <a:off x="749808" y="1874519"/>
+            <a:off x="749808" y="1847088"/>
             <a:ext cx="3163824" cy="411480"/>
           </a:xfrm>
           <a:prstGeom prst="rect">
@@ -12961,8 +12981,8 @@
         </p:nvSpPr>
         <p:spPr>
           <a:xfrm>
-            <a:off x="749808" y="2423160"/>
-            <a:ext cx="3163824" cy="1874519"/>
+            <a:off x="749808" y="2359152"/>
+            <a:ext cx="3163824" cy="1938528"/>
           </a:xfrm>
           <a:prstGeom prst="rect">
             <a:avLst/>
@@ -13003,7 +13023,7 @@
                 </a:solidFill>
                 <a:latin typeface="Malgun Gothic"/>
               </a:rPr>
-              <a:t>·  Agentic AI × 자산운용 접목</a:t>
+              <a:t>·  Agentic AI × 자산배분 접목</a:t>
             </a:r>
           </a:p>
           <a:p>
@@ -13019,7 +13039,7 @@
                 </a:solidFill>
                 <a:latin typeface="Malgun Gothic"/>
               </a:rPr>
-              <a:t>·  기관 도입 초기 단계 탐색</a:t>
+              <a:t>·  기관 AI Co-Pilot 도입 선도</a:t>
             </a:r>
           </a:p>
         </p:txBody>
@@ -13120,7 +13140,7 @@
         </p:nvSpPr>
         <p:spPr>
           <a:xfrm>
-            <a:off x="4498847" y="1874519"/>
+            <a:off x="4498847" y="1847088"/>
             <a:ext cx="3163824" cy="411480"/>
           </a:xfrm>
           <a:prstGeom prst="rect">
@@ -13159,8 +13179,8 @@
         </p:nvSpPr>
         <p:spPr>
           <a:xfrm>
-            <a:off x="4498847" y="2423160"/>
-            <a:ext cx="3163824" cy="1874519"/>
+            <a:off x="4498847" y="2359152"/>
+            <a:ext cx="3163824" cy="1938528"/>
           </a:xfrm>
           <a:prstGeom prst="rect">
             <a:avLst/>
@@ -13185,7 +13205,7 @@
                 </a:solidFill>
                 <a:latin typeface="Malgun Gothic"/>
               </a:rPr>
-              <a:t>·  연기금 · 국부펀드 실제 SAA 구조</a:t>
+              <a:t>·  연기금 실제 SAA/DAA 의사결정</a:t>
             </a:r>
           </a:p>
           <a:p>
@@ -13201,7 +13221,7 @@
                 </a:solidFill>
                 <a:latin typeface="Malgun Gothic"/>
               </a:rPr>
-              <a:t>·  위원회 · IPS 규정 등 거버넌스 반영</a:t>
+              <a:t>·  투자위원회 · IPS 거버넌스 완비</a:t>
             </a:r>
           </a:p>
           <a:p>
@@ -13217,7 +13237,7 @@
                 </a:solidFill>
                 <a:latin typeface="Malgun Gothic"/>
               </a:rPr>
-              <a:t>·  금융공학 이론과 실무의 결합</a:t>
+              <a:t>·  수리 최적화와 정성 토론 결합</a:t>
             </a:r>
           </a:p>
         </p:txBody>
@@ -13318,7 +13338,7 @@
         </p:nvSpPr>
         <p:spPr>
           <a:xfrm>
-            <a:off x="8247888" y="1874519"/>
+            <a:off x="8247888" y="1847088"/>
             <a:ext cx="3163824" cy="411480"/>
           </a:xfrm>
           <a:prstGeom prst="rect">
@@ -13357,8 +13377,8 @@
         </p:nvSpPr>
         <p:spPr>
           <a:xfrm>
-            <a:off x="8247888" y="2423160"/>
-            <a:ext cx="3163824" cy="1874519"/>
+            <a:off x="8247888" y="2359152"/>
+            <a:ext cx="3163824" cy="1938528"/>
           </a:xfrm>
           <a:prstGeom prst="rect">
             <a:avLst/>
@@ -13383,7 +13403,7 @@
                 </a:solidFill>
                 <a:latin typeface="Malgun Gothic"/>
               </a:rPr>
-              <a:t>·  명확한 수식 (OAS · BL · CVaR)</a:t>
+              <a:t>·  수학 공식 완비 (OAS · BL · CVaR)</a:t>
             </a:r>
           </a:p>
           <a:p>
@@ -13399,7 +13419,7 @@
                 </a:solidFill>
                 <a:latin typeface="Malgun Gothic"/>
               </a:rPr>
-              <a:t>·  18개 ETF 실제 데이터로 재현</a:t>
+              <a:t>·  18개 ETF 실데이터 159개월 검증</a:t>
             </a:r>
           </a:p>
           <a:p>
@@ -13415,7 +13435,7 @@
                 </a:solidFill>
                 <a:latin typeface="Malgun Gothic"/>
               </a:rPr>
-              <a:t>·  웹 시연으로 즉시 검증 가능</a:t>
+              <a:t>·  24/7 웹 시연으로 실효성 입증</a:t>
             </a:r>
           </a:p>
         </p:txBody>
@@ -13498,7 +13518,7 @@
                 </a:solidFill>
                 <a:latin typeface="Malgun Gothic"/>
               </a:rPr>
-              <a:t>목표  →  논문의 50개 에이전트 구조를 실제 작동하는 웹 시스템으로 재현</a:t>
+              <a:t>목표  →  논문의 50개 에이전트 아키텍처를 실제 데이터 기반의 실동작 웹 플랫폼으로 재현</a:t>
             </a:r>
           </a:p>
         </p:txBody>
@@ -13638,7 +13658,7 @@
                 </a:solidFill>
                 <a:latin typeface="Malgun Gothic"/>
               </a:rPr>
-              <a:t>시스템 아키텍처 구성</a:t>
+              <a:t>시스템 아키텍처 및 기초데이터 체계</a:t>
             </a:r>
           </a:p>
         </p:txBody>
@@ -13735,7 +13755,7 @@
         <p:spPr>
           <a:xfrm>
             <a:off x="548640" y="1737360"/>
-            <a:ext cx="2468880" cy="2743200"/>
+            <a:ext cx="2468880" cy="3017520"/>
           </a:xfrm>
           <a:prstGeom prst="rect">
             <a:avLst/>
@@ -13822,7 +13842,7 @@
         </p:nvSpPr>
         <p:spPr>
           <a:xfrm>
-            <a:off x="749808" y="1965960"/>
+            <a:off x="749808" y="1938528"/>
             <a:ext cx="2066544" cy="411480"/>
           </a:xfrm>
           <a:prstGeom prst="rect">
@@ -13842,13 +13862,13 @@
               </a:spcAft>
             </a:pPr>
             <a:r>
-              <a:rPr sz="1900" b="1">
+              <a:rPr sz="1700" b="1">
                 <a:solidFill>
                   <a:srgbClr val="051C2C"/>
                 </a:solidFill>
                 <a:latin typeface="Malgun Gothic"/>
               </a:rPr>
-              <a:t>데이터 계층</a:t>
+              <a:t>데이터 계층 (실데이터)</a:t>
             </a:r>
           </a:p>
         </p:txBody>
@@ -13861,8 +13881,8 @@
         </p:nvSpPr>
         <p:spPr>
           <a:xfrm>
-            <a:off x="749808" y="2514600"/>
-            <a:ext cx="2066544" cy="1874519"/>
+            <a:off x="749808" y="2450591"/>
+            <a:ext cx="2066544" cy="2212848"/>
           </a:xfrm>
           <a:prstGeom prst="rect">
             <a:avLst/>
@@ -13877,49 +13897,65 @@
           <a:p>
             <a:pPr algn="l">
               <a:spcAft>
-                <a:spcPts val="700"/>
-              </a:spcAft>
-            </a:pPr>
-            <a:r>
-              <a:rPr sz="1350" b="0">
+                <a:spcPts val="500"/>
+              </a:spcAft>
+            </a:pPr>
+            <a:r>
+              <a:rPr sz="1200" b="0">
                 <a:solidFill>
                   <a:srgbClr val="475569"/>
                 </a:solidFill>
                 <a:latin typeface="Malgun Gothic"/>
               </a:rPr>
-              <a:t>·  18개 ETF 월간 수익률</a:t>
-            </a:r>
-          </a:p>
-          <a:p>
-            <a:pPr algn="l">
-              <a:spcAft>
-                <a:spcPts val="700"/>
-              </a:spcAft>
-            </a:pPr>
-            <a:r>
-              <a:rPr sz="1350" b="0">
+              <a:t>·  야후 파이낸스 실데이터 159개월</a:t>
+            </a:r>
+          </a:p>
+          <a:p>
+            <a:pPr algn="l">
+              <a:spcAft>
+                <a:spcPts val="500"/>
+              </a:spcAft>
+            </a:pPr>
+            <a:r>
+              <a:rPr sz="1200" b="0">
                 <a:solidFill>
                   <a:srgbClr val="475569"/>
                 </a:solidFill>
                 <a:latin typeface="Malgun Gothic"/>
               </a:rPr>
-              <a:t>·  거시지표 (성장·물가·금리)</a:t>
-            </a:r>
-          </a:p>
-          <a:p>
-            <a:pPr algn="l">
-              <a:spcAft>
-                <a:spcPts val="700"/>
-              </a:spcAft>
-            </a:pPr>
-            <a:r>
-              <a:rPr sz="1350" b="0">
+              <a:t>·  (2013-07 ~ 2026-09 수정 총수익률)</a:t>
+            </a:r>
+          </a:p>
+          <a:p>
+            <a:pPr algn="l">
+              <a:spcAft>
+                <a:spcPts val="500"/>
+              </a:spcAft>
+            </a:pPr>
+            <a:r>
+              <a:rPr sz="1200" b="0">
                 <a:solidFill>
                   <a:srgbClr val="475569"/>
                 </a:solidFill>
                 <a:latin typeface="Malgun Gothic"/>
               </a:rPr>
-              <a:t>·  야후 파이낸스 실데이터</a:t>
+              <a:t>·  18개 대표 ETF 유동성 대용치</a:t>
+            </a:r>
+          </a:p>
+          <a:p>
+            <a:pPr algn="l">
+              <a:spcAft>
+                <a:spcPts val="500"/>
+              </a:spcAft>
+            </a:pPr>
+            <a:r>
+              <a:rPr sz="1200" b="0">
+                <a:solidFill>
+                  <a:srgbClr val="475569"/>
+                </a:solidFill>
+                <a:latin typeface="Malgun Gothic"/>
+              </a:rPr>
+              <a:t>·  FRED 실시간 거시지표 (성장·물가·금리)</a:t>
             </a:r>
           </a:p>
         </p:txBody>
@@ -13932,7 +13968,7 @@
         </p:nvSpPr>
         <p:spPr>
           <a:xfrm>
-            <a:off x="3035808" y="2743200"/>
+            <a:off x="3035808" y="2926080"/>
             <a:ext cx="365760" cy="548640"/>
           </a:xfrm>
           <a:prstGeom prst="rect">
@@ -13972,7 +14008,7 @@
         <p:spPr>
           <a:xfrm>
             <a:off x="3419856" y="1737360"/>
-            <a:ext cx="2468880" cy="2743200"/>
+            <a:ext cx="2468880" cy="3017520"/>
           </a:xfrm>
           <a:prstGeom prst="rect">
             <a:avLst/>
@@ -14059,7 +14095,7 @@
         </p:nvSpPr>
         <p:spPr>
           <a:xfrm>
-            <a:off x="3621024" y="1965960"/>
+            <a:off x="3621024" y="1938528"/>
             <a:ext cx="2066544" cy="411480"/>
           </a:xfrm>
           <a:prstGeom prst="rect">
@@ -14079,7 +14115,7 @@
               </a:spcAft>
             </a:pPr>
             <a:r>
-              <a:rPr sz="1900" b="1">
+              <a:rPr sz="1700" b="1">
                 <a:solidFill>
                   <a:srgbClr val="051C2C"/>
                 </a:solidFill>
@@ -14098,8 +14134,8 @@
         </p:nvSpPr>
         <p:spPr>
           <a:xfrm>
-            <a:off x="3621024" y="2514600"/>
-            <a:ext cx="2066544" cy="1874519"/>
+            <a:off x="3621024" y="2450591"/>
+            <a:ext cx="2066544" cy="2212848"/>
           </a:xfrm>
           <a:prstGeom prst="rect">
             <a:avLst/>
@@ -14114,49 +14150,65 @@
           <a:p>
             <a:pPr algn="l">
               <a:spcAft>
-                <a:spcPts val="700"/>
-              </a:spcAft>
-            </a:pPr>
-            <a:r>
-              <a:rPr sz="1350" b="0">
+                <a:spcPts val="500"/>
+              </a:spcAft>
+            </a:pPr>
+            <a:r>
+              <a:rPr sz="1200" b="0">
                 <a:solidFill>
                   <a:srgbClr val="475569"/>
                 </a:solidFill>
                 <a:latin typeface="Malgun Gothic"/>
               </a:rPr>
-              <a:t>·  Python · FastAPI</a:t>
-            </a:r>
-          </a:p>
-          <a:p>
-            <a:pPr algn="l">
-              <a:spcAft>
-                <a:spcPts val="700"/>
-              </a:spcAft>
-            </a:pPr>
-            <a:r>
-              <a:rPr sz="1350" b="0">
+              <a:t>·  Python · FastAPI 프레임워크</a:t>
+            </a:r>
+          </a:p>
+          <a:p>
+            <a:pPr algn="l">
+              <a:spcAft>
+                <a:spcPts val="500"/>
+              </a:spcAft>
+            </a:pPr>
+            <a:r>
+              <a:rPr sz="1200" b="0">
                 <a:solidFill>
                   <a:srgbClr val="475569"/>
                 </a:solidFill>
                 <a:latin typeface="Malgun Gothic"/>
               </a:rPr>
-              <a:t>·  6단계 파이프라인 오케스트레이션</a:t>
-            </a:r>
-          </a:p>
-          <a:p>
-            <a:pPr algn="l">
-              <a:spcAft>
-                <a:spcPts val="700"/>
-              </a:spcAft>
-            </a:pPr>
-            <a:r>
-              <a:rPr sz="1350" b="0">
+              <a:t>·  NumPy · SciPy 결정론적 행렬 연산</a:t>
+            </a:r>
+          </a:p>
+          <a:p>
+            <a:pPr algn="l">
+              <a:spcAft>
+                <a:spcPts val="500"/>
+              </a:spcAft>
+            </a:pPr>
+            <a:r>
+              <a:rPr sz="1200" b="0">
                 <a:solidFill>
                   <a:srgbClr val="475569"/>
                 </a:solidFill>
                 <a:latin typeface="Malgun Gothic"/>
               </a:rPr>
-              <a:t>·  NumPy · SciPy 결정론적 계산</a:t>
+              <a:t>·  Exhibit 5 4대 계열 21개 모델 최적화</a:t>
+            </a:r>
+          </a:p>
+          <a:p>
+            <a:pPr algn="l">
+              <a:spcAft>
+                <a:spcPts val="500"/>
+              </a:spcAft>
+            </a:pPr>
+            <a:r>
+              <a:rPr sz="1200" b="0">
+                <a:solidFill>
+                  <a:srgbClr val="475569"/>
+                </a:solidFill>
+                <a:latin typeface="Malgun Gothic"/>
+              </a:rPr>
+              <a:t>·  OAS 공분산 수축 및 보르다 투표 집계</a:t>
             </a:r>
           </a:p>
         </p:txBody>
@@ -14169,7 +14221,7 @@
         </p:nvSpPr>
         <p:spPr>
           <a:xfrm>
-            <a:off x="5907024" y="2743200"/>
+            <a:off x="5907024" y="2926080"/>
             <a:ext cx="365760" cy="548640"/>
           </a:xfrm>
           <a:prstGeom prst="rect">
@@ -14209,7 +14261,7 @@
         <p:spPr>
           <a:xfrm>
             <a:off x="6291072" y="1737360"/>
-            <a:ext cx="2468880" cy="2743200"/>
+            <a:ext cx="2468880" cy="3017520"/>
           </a:xfrm>
           <a:prstGeom prst="rect">
             <a:avLst/>
@@ -14296,7 +14348,7 @@
         </p:nvSpPr>
         <p:spPr>
           <a:xfrm>
-            <a:off x="6492240" y="1965960"/>
+            <a:off x="6492240" y="1938528"/>
             <a:ext cx="2066544" cy="411480"/>
           </a:xfrm>
           <a:prstGeom prst="rect">
@@ -14316,7 +14368,7 @@
               </a:spcAft>
             </a:pPr>
             <a:r>
-              <a:rPr sz="1900" b="1">
+              <a:rPr sz="1700" b="1">
                 <a:solidFill>
                   <a:srgbClr val="051C2C"/>
                 </a:solidFill>
@@ -14335,8 +14387,8 @@
         </p:nvSpPr>
         <p:spPr>
           <a:xfrm>
-            <a:off x="6492240" y="2514600"/>
-            <a:ext cx="2066544" cy="1874519"/>
+            <a:off x="6492240" y="2450591"/>
+            <a:ext cx="2066544" cy="2212848"/>
           </a:xfrm>
           <a:prstGeom prst="rect">
             <a:avLst/>
@@ -14351,49 +14403,65 @@
           <a:p>
             <a:pPr algn="l">
               <a:spcAft>
-                <a:spcPts val="700"/>
-              </a:spcAft>
-            </a:pPr>
-            <a:r>
-              <a:rPr sz="1350" b="0">
+                <a:spcPts val="500"/>
+              </a:spcAft>
+            </a:pPr>
+            <a:r>
+              <a:rPr sz="1200" b="0">
                 <a:solidFill>
                   <a:srgbClr val="475569"/>
                 </a:solidFill>
                 <a:latin typeface="Malgun Gothic"/>
               </a:rPr>
-              <a:t>·  React · TypeScript · Tailwind</a:t>
-            </a:r>
-          </a:p>
-          <a:p>
-            <a:pPr algn="l">
-              <a:spcAft>
-                <a:spcPts val="700"/>
-              </a:spcAft>
-            </a:pPr>
-            <a:r>
-              <a:rPr sz="1350" b="0">
+              <a:t>·  React 19 · TypeScript · Tailwind CSS</a:t>
+            </a:r>
+          </a:p>
+          <a:p>
+            <a:pPr algn="l">
+              <a:spcAft>
+                <a:spcPts val="500"/>
+              </a:spcAft>
+            </a:pPr>
+            <a:r>
+              <a:rPr sz="1200" b="0">
                 <a:solidFill>
                   <a:srgbClr val="475569"/>
                 </a:solidFill>
                 <a:latin typeface="Malgun Gothic"/>
               </a:rPr>
-              <a:t>·  자산배분 · 투표 · 성과 진단 탭</a:t>
-            </a:r>
-          </a:p>
-          <a:p>
-            <a:pPr algn="l">
-              <a:spcAft>
-                <a:spcPts val="700"/>
-              </a:spcAft>
-            </a:pPr>
-            <a:r>
-              <a:rPr sz="1350" b="0">
+              <a:t>·  거버넌스 L3 상태 및 6단계 스테퍼</a:t>
+            </a:r>
+          </a:p>
+          <a:p>
+            <a:pPr algn="l">
+              <a:spcAft>
+                <a:spcPts val="500"/>
+              </a:spcAft>
+            </a:pPr>
+            <a:r>
+              <a:rPr sz="1200" b="0">
                 <a:solidFill>
                   <a:srgbClr val="475569"/>
                 </a:solidFill>
                 <a:latin typeface="Malgun Gothic"/>
               </a:rPr>
-              <a:t>·  IPS 실시간 재실행</a:t>
+              <a:t>·  자산배분 탭 · 보르다 투표 · 진단 차트</a:t>
+            </a:r>
+          </a:p>
+          <a:p>
+            <a:pPr algn="l">
+              <a:spcAft>
+                <a:spcPts val="500"/>
+              </a:spcAft>
+            </a:pPr>
+            <a:r>
+              <a:rPr sz="1200" b="0">
+                <a:solidFill>
+                  <a:srgbClr val="475569"/>
+                </a:solidFill>
+                <a:latin typeface="Malgun Gothic"/>
+              </a:rPr>
+              <a:t>·  IPS 파라미터 즉각 재실행 인터페이스</a:t>
             </a:r>
           </a:p>
         </p:txBody>
@@ -14406,7 +14474,7 @@
         </p:nvSpPr>
         <p:spPr>
           <a:xfrm>
-            <a:off x="8778240" y="2743200"/>
+            <a:off x="8778240" y="2926080"/>
             <a:ext cx="365760" cy="548640"/>
           </a:xfrm>
           <a:prstGeom prst="rect">
@@ -14446,7 +14514,7 @@
         <p:spPr>
           <a:xfrm>
             <a:off x="9162288" y="1737360"/>
-            <a:ext cx="2468880" cy="2743200"/>
+            <a:ext cx="2468880" cy="3017520"/>
           </a:xfrm>
           <a:prstGeom prst="rect">
             <a:avLst/>
@@ -14533,7 +14601,7 @@
         </p:nvSpPr>
         <p:spPr>
           <a:xfrm>
-            <a:off x="9363456" y="1965960"/>
+            <a:off x="9363456" y="1938528"/>
             <a:ext cx="2066544" cy="411480"/>
           </a:xfrm>
           <a:prstGeom prst="rect">
@@ -14553,7 +14621,7 @@
               </a:spcAft>
             </a:pPr>
             <a:r>
-              <a:rPr sz="1900" b="1">
+              <a:rPr sz="1700" b="1">
                 <a:solidFill>
                   <a:srgbClr val="051C2C"/>
                 </a:solidFill>
@@ -14572,8 +14640,8 @@
         </p:nvSpPr>
         <p:spPr>
           <a:xfrm>
-            <a:off x="9363456" y="2514600"/>
-            <a:ext cx="2066544" cy="1874519"/>
+            <a:off x="9363456" y="2450591"/>
+            <a:ext cx="2066544" cy="2212848"/>
           </a:xfrm>
           <a:prstGeom prst="rect">
             <a:avLst/>
@@ -14588,63 +14656,125 @@
           <a:p>
             <a:pPr algn="l">
               <a:spcAft>
-                <a:spcPts val="700"/>
-              </a:spcAft>
-            </a:pPr>
-            <a:r>
-              <a:rPr sz="1350" b="0">
+                <a:spcPts val="500"/>
+              </a:spcAft>
+            </a:pPr>
+            <a:r>
+              <a:rPr sz="1200" b="0">
                 <a:solidFill>
                   <a:srgbClr val="475569"/>
                 </a:solidFill>
                 <a:latin typeface="Malgun Gothic"/>
               </a:rPr>
-              <a:t>·  Docker 멀티 스테이지 빌드</a:t>
-            </a:r>
-          </a:p>
-          <a:p>
-            <a:pPr algn="l">
-              <a:spcAft>
-                <a:spcPts val="700"/>
-              </a:spcAft>
-            </a:pPr>
-            <a:r>
-              <a:rPr sz="1350" b="0">
+              <a:t>·  Docker 경량 멀티 스테이지 빌드</a:t>
+            </a:r>
+          </a:p>
+          <a:p>
+            <a:pPr algn="l">
+              <a:spcAft>
+                <a:spcPts val="500"/>
+              </a:spcAft>
+            </a:pPr>
+            <a:r>
+              <a:rPr sz="1200" b="0">
                 <a:solidFill>
                   <a:srgbClr val="475569"/>
                 </a:solidFill>
                 <a:latin typeface="Malgun Gothic"/>
               </a:rPr>
-              <a:t>·  Render 클라우드 24/7 서비스</a:t>
-            </a:r>
-          </a:p>
-          <a:p>
-            <a:pPr algn="l">
-              <a:spcAft>
-                <a:spcPts val="700"/>
-              </a:spcAft>
-            </a:pPr>
-            <a:r>
-              <a:rPr sz="1350" b="0">
+              <a:t>·  Render 클라우드 24/7 무중단 호스팅</a:t>
+            </a:r>
+          </a:p>
+          <a:p>
+            <a:pPr algn="l">
+              <a:spcAft>
+                <a:spcPts val="500"/>
+              </a:spcAft>
+            </a:pPr>
+            <a:r>
+              <a:rPr sz="1200" b="0">
                 <a:solidFill>
                   <a:srgbClr val="475569"/>
                 </a:solidFill>
                 <a:latin typeface="Malgun Gothic"/>
               </a:rPr>
-              <a:t>·  GitHub CI/CD 연동</a:t>
-            </a:r>
-          </a:p>
-        </p:txBody>
-      </p:sp>
-      <p:sp>
-        <p:nvSpPr>
-          <p:cNvPr id="26" name="TextBox 25"/>
-          <p:cNvSpPr txBox="1"/>
-          <p:nvPr/>
-        </p:nvSpPr>
-        <p:spPr>
-          <a:xfrm>
-            <a:off x="548640" y="4937760"/>
-            <a:ext cx="10972800" cy="365760"/>
+              <a:t>·  GitHub Actions CI/CD 완전 자동화</a:t>
+            </a:r>
+          </a:p>
+          <a:p>
+            <a:pPr algn="l">
+              <a:spcAft>
+                <a:spcPts val="500"/>
+              </a:spcAft>
+            </a:pPr>
+            <a:r>
+              <a:rPr sz="1200" b="0">
+                <a:solidFill>
+                  <a:srgbClr val="475569"/>
+                </a:solidFill>
+                <a:latin typeface="Malgun Gothic"/>
+              </a:rPr>
+              <a:t>·  반응형 웹 UI (데스크톱/모바일)</a:t>
+            </a:r>
+          </a:p>
+        </p:txBody>
+      </p:sp>
+      <p:sp>
+        <p:nvSpPr>
+          <p:cNvPr id="26" name="Rectangle 25"/>
+          <p:cNvSpPr/>
+          <p:nvPr/>
+        </p:nvSpPr>
+        <p:spPr>
+          <a:xfrm>
+            <a:off x="548640" y="5029200"/>
+            <a:ext cx="11091672" cy="822960"/>
+          </a:xfrm>
+          <a:prstGeom prst="rect">
+            <a:avLst/>
+          </a:prstGeom>
+          <a:solidFill>
+            <a:srgbClr val="EFF6FF"/>
+          </a:solidFill>
+          <a:ln w="12700">
+            <a:solidFill>
+              <a:srgbClr val="0052CC"/>
+            </a:solidFill>
+          </a:ln>
+          <a:effectLst/>
+        </p:spPr>
+        <p:style>
+          <a:lnRef idx="1">
+            <a:schemeClr val="accent1"/>
+          </a:lnRef>
+          <a:fillRef idx="3">
+            <a:schemeClr val="accent1"/>
+          </a:fillRef>
+          <a:effectRef idx="2">
+            <a:schemeClr val="accent1"/>
+          </a:effectRef>
+          <a:fontRef idx="minor">
+            <a:schemeClr val="lt1"/>
+          </a:fontRef>
+        </p:style>
+        <p:txBody>
+          <a:bodyPr rtlCol="0" anchor="ctr"/>
+          <a:lstStyle/>
+          <a:p>
+            <a:pPr algn="ctr"/>
+          </a:p>
+        </p:txBody>
+      </p:sp>
+      <p:sp>
+        <p:nvSpPr>
+          <p:cNvPr id="27" name="TextBox 26"/>
+          <p:cNvSpPr txBox="1"/>
+          <p:nvPr/>
+        </p:nvSpPr>
+        <p:spPr>
+          <a:xfrm>
+            <a:off x="731520" y="5074920"/>
+            <a:ext cx="10698480" cy="731520"/>
           </a:xfrm>
           <a:prstGeom prst="rect">
             <a:avLst/>
@@ -14659,72 +14789,33 @@
           <a:p>
             <a:pPr algn="l">
               <a:spcAft>
-                <a:spcPts val="400"/>
-              </a:spcAft>
-            </a:pPr>
-            <a:r>
-              <a:rPr sz="1400" b="1">
-                <a:solidFill>
-                  <a:srgbClr val="051C2C"/>
-                </a:solidFill>
-                <a:latin typeface="Malgun Gothic"/>
-              </a:rPr>
-              <a:t>핵심 구현 원칙</a:t>
-            </a:r>
-          </a:p>
-        </p:txBody>
-      </p:sp>
-      <p:sp>
-        <p:nvSpPr>
-          <p:cNvPr id="27" name="TextBox 26"/>
-          <p:cNvSpPr txBox="1"/>
-          <p:nvPr/>
-        </p:nvSpPr>
-        <p:spPr>
-          <a:xfrm>
-            <a:off x="548640" y="5303520"/>
-            <a:ext cx="10972800" cy="731520"/>
-          </a:xfrm>
-          <a:prstGeom prst="rect">
-            <a:avLst/>
-          </a:prstGeom>
-          <a:noFill/>
-        </p:spPr>
-        <p:txBody>
-          <a:bodyPr wrap="square" anchor="t" lIns="0" rIns="0" tIns="0" bIns="0">
-            <a:spAutoFit/>
-          </a:bodyPr>
-          <a:lstStyle/>
-          <a:p>
-            <a:pPr algn="l">
-              <a:spcAft>
-                <a:spcPts val="400"/>
-              </a:spcAft>
-            </a:pPr>
-            <a:r>
-              <a:rPr sz="1300" b="0">
-                <a:solidFill>
-                  <a:srgbClr val="475569"/>
-                </a:solidFill>
-                <a:latin typeface="Malgun Gothic"/>
-              </a:rPr>
-              <a:t>·  수치 계산: 결정론적 코드 (NumPy/SciPy, 재현 가능, 환각 0%)</a:t>
-            </a:r>
-          </a:p>
-          <a:p>
-            <a:pPr algn="l">
-              <a:spcAft>
-                <a:spcPts val="400"/>
-              </a:spcAft>
-            </a:pPr>
-            <a:r>
-              <a:rPr sz="1300" b="0">
-                <a:solidFill>
-                  <a:srgbClr val="475569"/>
-                </a:solidFill>
-                <a:latin typeface="Malgun Gothic"/>
-              </a:rPr>
-              <a:t>·  해설 및 토론: LLM 하이브리드 모드 (API 키 없이도 시뮬레이션 지원)</a:t>
+                <a:spcPts val="300"/>
+              </a:spcAft>
+            </a:pPr>
+            <a:r>
+              <a:rPr sz="1250" b="0">
+                <a:solidFill>
+                  <a:srgbClr val="0F172A"/>
+                </a:solidFill>
+                <a:latin typeface="Malgun Gothic"/>
+              </a:rPr>
+              <a:t>·  데이터 투명성: 상용 벤더가 아닌 야후 파이낸스 159개월 실데이터(18개 ETF)로 완전 공개 검증 가능</a:t>
+            </a:r>
+          </a:p>
+          <a:p>
+            <a:pPr algn="l">
+              <a:spcAft>
+                <a:spcPts val="300"/>
+              </a:spcAft>
+            </a:pPr>
+            <a:r>
+              <a:rPr sz="1250" b="0">
+                <a:solidFill>
+                  <a:srgbClr val="0F172A"/>
+                </a:solidFill>
+                <a:latin typeface="Malgun Gothic"/>
+              </a:rPr>
+              <a:t>·  Tool Determinism: 수치 연산은 100% 파이썬 코드가 전담하여 환각 0% 보장, LLM은 거버넌스 해설 전담</a:t>
             </a:r>
           </a:p>
         </p:txBody>
@@ -14864,7 +14955,7 @@
                 </a:solidFill>
                 <a:latin typeface="Malgun Gothic"/>
               </a:rPr>
-              <a:t>메인 대시보드 및 6단계 파이프라인 (실화면)</a:t>
+              <a:t>메인 대시보드 및 핵심 거버넌스 지표 (실화면)</a:t>
             </a:r>
           </a:p>
         </p:txBody>
@@ -15048,7 +15139,7 @@
         </p:nvSpPr>
         <p:spPr>
           <a:xfrm>
-            <a:off x="749808" y="1691640"/>
+            <a:off x="749808" y="1664208"/>
             <a:ext cx="3438144" cy="411480"/>
           </a:xfrm>
           <a:prstGeom prst="rect">
@@ -15074,7 +15165,7 @@
                 </a:solidFill>
                 <a:latin typeface="Malgun Gothic"/>
               </a:rPr>
-              <a:t>화면 구성 및 핵심 지표</a:t>
+              <a:t>거버넌스 L3 &amp; 핵심 성과 지표</a:t>
             </a:r>
           </a:p>
         </p:txBody>
@@ -15087,8 +15178,8 @@
         </p:nvSpPr>
         <p:spPr>
           <a:xfrm>
-            <a:off x="749808" y="2240280"/>
-            <a:ext cx="3438144" cy="3703320"/>
+            <a:off x="749808" y="2176272"/>
+            <a:ext cx="3438144" cy="3767328"/>
           </a:xfrm>
           <a:prstGeom prst="rect">
             <a:avLst/>
@@ -15113,7 +15204,7 @@
                 </a:solidFill>
                 <a:latin typeface="Malgun Gothic"/>
               </a:rPr>
-              <a:t>·  거버넌스 L3: 조건부 자율 SAA 운용</a:t>
+              <a:t>·  거버넌스 L3: 투자위원회 지원 AI Co-Pilot</a:t>
             </a:r>
           </a:p>
           <a:p>
@@ -15129,7 +15220,7 @@
                 </a:solidFill>
                 <a:latin typeface="Malgun Gothic"/>
               </a:rPr>
-              <a:t>·  IPS 적격 심사: 21개 후보 중 2개만 통과</a:t>
+              <a:t>·  IPS 적격 심사: 21개 후보 중 2개만 최종 통과</a:t>
             </a:r>
           </a:p>
           <a:p>
@@ -15145,7 +15236,7 @@
                 </a:solidFill>
                 <a:latin typeface="Malgun Gothic"/>
               </a:rPr>
-              <a:t>·  예상 명목수익률: 5.75% (실질 +3.3%)</a:t>
+              <a:t>·  예상 명목수익률: 5.75% (실질수익률 +3.3%)</a:t>
             </a:r>
           </a:p>
           <a:p>
@@ -15161,7 +15252,7 @@
                 </a:solidFill>
                 <a:latin typeface="Malgun Gothic"/>
               </a:rPr>
-              <a:t>·  사전 연간변동성: 8.85% (밴드 8~12% 충족)</a:t>
+              <a:t>·  사전 연간변동성: 8.85% (IPS [8~12%] 충족)</a:t>
             </a:r>
           </a:p>
           <a:p>
@@ -15193,7 +15284,7 @@
                 </a:solidFill>
                 <a:latin typeface="Malgun Gothic"/>
               </a:rPr>
-              <a:t>·  예상 최대낙폭: -18.59% (하방 방어력 우수)</a:t>
+              <a:t>·  예상 최대낙폭: -18.59% (60/40 -34.3% 대비 방어)</a:t>
             </a:r>
           </a:p>
           <a:p>
@@ -15209,7 +15300,7 @@
                 </a:solidFill>
                 <a:latin typeface="Malgun Gothic"/>
               </a:rPr>
-              <a:t>·  트래킹 에러: 0.77% (한도 &lt; 6% 준수)</a:t>
+              <a:t>·  사전 트래킹 에러: 0.77% (IPS &lt; 6.0% 준수)</a:t>
             </a:r>
           </a:p>
           <a:p>
@@ -15225,7 +15316,7 @@
                 </a:solidFill>
                 <a:latin typeface="Malgun Gothic"/>
               </a:rPr>
-              <a:t>·  유효 자산수: 10.2개 (다변화 확보)</a:t>
+              <a:t>·  유효 자산수: 10.2개 (충분한 자산 다변화)</a:t>
             </a:r>
           </a:p>
         </p:txBody>
@@ -15619,7 +15710,7 @@
         </p:nvSpPr>
         <p:spPr>
           <a:xfrm>
-            <a:off x="749808" y="1691640"/>
+            <a:off x="749808" y="1664208"/>
             <a:ext cx="3438144" cy="411480"/>
           </a:xfrm>
           <a:prstGeom prst="rect">
@@ -15645,7 +15736,7 @@
                 </a:solidFill>
                 <a:latin typeface="Malgun Gothic"/>
               </a:rPr>
-              <a:t>자산 배분 및 벤치마크 진단</a:t>
+              <a:t>대자산군 배분 및 벤치마크 진단</a:t>
             </a:r>
           </a:p>
         </p:txBody>
@@ -15658,8 +15749,8 @@
         </p:nvSpPr>
         <p:spPr>
           <a:xfrm>
-            <a:off x="749808" y="2240280"/>
-            <a:ext cx="3438144" cy="3703320"/>
+            <a:off x="749808" y="2176272"/>
+            <a:ext cx="3438144" cy="3767328"/>
           </a:xfrm>
           <a:prstGeom prst="rect">
             <a:avLst/>
@@ -15684,7 +15775,7 @@
                 </a:solidFill>
                 <a:latin typeface="Malgun Gothic"/>
               </a:rPr>
-              <a:t>·  주식군 (Equity): 56.49%</a:t>
+              <a:t>·  주식군 (Equity): 56.49% (대형·성장·가치·중소)</a:t>
             </a:r>
           </a:p>
           <a:p>
@@ -15700,7 +15791,7 @@
                 </a:solidFill>
                 <a:latin typeface="Malgun Gothic"/>
               </a:rPr>
-              <a:t>·  채권군 (Fixed Income): 40.71%</a:t>
+              <a:t>·  채권군 (Fixed Income): 40.71% (중기·단기·장기·회사채)</a:t>
             </a:r>
           </a:p>
           <a:p>
@@ -15716,7 +15807,7 @@
                 </a:solidFill>
                 <a:latin typeface="Malgun Gothic"/>
               </a:rPr>
-              <a:t>·  실물자산 (Real Assets): 1.65%</a:t>
+              <a:t>·  실물자산 (Real Assets): 1.65% (금·원자재·리츠)</a:t>
             </a:r>
           </a:p>
           <a:p>
@@ -15732,7 +15823,7 @@
                 </a:solidFill>
                 <a:latin typeface="Malgun Gothic"/>
               </a:rPr>
-              <a:t>·  현금 버퍼 (Cash): 1.17%</a:t>
+              <a:t>·  현금 버퍼 (Cash): 1.17% (초단기국채 유동성)</a:t>
             </a:r>
           </a:p>
           <a:p>
@@ -15748,7 +15839,7 @@
                 </a:solidFill>
                 <a:latin typeface="Malgun Gothic"/>
               </a:rPr>
-              <a:t>·  스태그플레이션 방어: 주식 언더웨이트</a:t>
+              <a:t>·  거시 국면 대응: 스태그플레이션 방어 주식 언더웨이트</a:t>
             </a:r>
           </a:p>
           <a:p>
@@ -15764,7 +15855,7 @@
                 </a:solidFill>
                 <a:latin typeface="Malgun Gothic"/>
               </a:rPr>
-              <a:t>·  채권 듀레이션 및 현금 버퍼 확보</a:t>
+              <a:t>·  채권 듀레이션 분산 및 현금 확보로 완충력 강화</a:t>
             </a:r>
           </a:p>
           <a:p>
@@ -15780,7 +15871,7 @@
                 </a:solidFill>
                 <a:latin typeface="Malgun Gothic"/>
               </a:rPr>
-              <a:t>·  최대 낙폭 개선: -34.3% → -18.59%</a:t>
+              <a:t>·  최대 낙폭(MDD): -34.3% → -18.59%로 대폭 개선</a:t>
             </a:r>
           </a:p>
           <a:p>
@@ -15796,7 +15887,7 @@
                 </a:solidFill>
                 <a:latin typeface="Malgun Gothic"/>
               </a:rPr>
-              <a:t>·  사전 트래킹 에러: 0.77% (IPS 한도 준수)</a:t>
+              <a:t>·  사전 트래킹 에러: 0.77% (벤치마크 추종 균형)</a:t>
             </a:r>
           </a:p>
         </p:txBody>

</xml_diff>